<commit_message>
Update experiment review with data expansion plan
</commit_message>
<xml_diff>
--- a/reports/wilor_experiment_review/WiLoR_experiments_and_scale_diagnosis.pptx
+++ b/reports/wilor_experiment_review/WiLoR_experiments_and_scale_diagnosis.pptx
@@ -17,6 +17,10 @@
     <p:sldId id="265" r:id="rId17"/>
     <p:sldId id="266" r:id="rId18"/>
     <p:sldId id="267" r:id="rId19"/>
+    <p:sldId id="268" r:id="rId20"/>
+    <p:sldId id="269" r:id="rId21"/>
+    <p:sldId id="270" r:id="rId22"/>
+    <p:sldId id="271" r:id="rId23"/>
   </p:sldIdLst>
   <p:sldSz cx="12191695" cy="6858000" type="screen4x3"/>
   <p:notesSz cx="6858000" cy="9144000"/>
@@ -738,7 +742,307 @@
           <a:lstStyle/>
           <a:p>
             <a:r>
-              <a:t>Evidence: Sources: all local scale_diagnostic reports; next steps are proposed, not completed</a:t>
+              <a:t>Evidence: Sources: evaluation/freihand_annotated_interventions_full/{summary.csv,provenance.json}</a:t>
+            </a:r>
+          </a:p>
+          <a:p>
+            <a:r>
+              <a:t>Local project root: /data/xjiang390/projects/WiLoR</a:t>
+            </a:r>
+          </a:p>
+        </p:txBody>
+      </p:sp>
+      <p:sp>
+        <p:nvSpPr>
+          <p:cNvPr id="4" name="Slide Number Placeholder 3"/>
+          <p:cNvSpPr>
+            <a:spLocks noGrp="1"/>
+          </p:cNvSpPr>
+          <p:nvPr>
+            <p:ph type="sldNum" idx="5" sz="quarter"/>
+          </p:nvPr>
+        </p:nvSpPr>
+        <p:spPr/>
+      </p:sp>
+    </p:spTree>
+  </p:cSld>
+  <p:clrMapOvr>
+    <a:masterClrMapping/>
+  </p:clrMapOvr>
+</p:notes>
+</file>
+
+<file path=ppt/notesSlides/notesSlide13.xml><?xml version="1.0" encoding="utf-8"?>
+<p:notes xmlns:a="http://schemas.openxmlformats.org/drawingml/2006/main" xmlns:p="http://schemas.openxmlformats.org/presentationml/2006/main" xmlns:r="http://schemas.openxmlformats.org/officeDocument/2006/relationships">
+  <p:cSld>
+    <p:spTree>
+      <p:nvGrpSpPr>
+        <p:cNvPr id="1" name=""/>
+        <p:cNvGrpSpPr/>
+        <p:nvPr/>
+      </p:nvGrpSpPr>
+      <p:grpSpPr>
+        <a:xfrm>
+          <a:off x="0" y="0"/>
+          <a:ext cx="0" cy="0"/>
+          <a:chOff x="0" y="0"/>
+          <a:chExt cx="0" cy="0"/>
+        </a:xfrm>
+      </p:grpSpPr>
+      <p:sp>
+        <p:nvSpPr>
+          <p:cNvPr id="2" name="Slide Image Placeholder 1"/>
+          <p:cNvSpPr>
+            <a:spLocks noGrp="1"/>
+          </p:cNvSpPr>
+          <p:nvPr>
+            <p:ph type="sldImg" idx="2"/>
+          </p:nvPr>
+        </p:nvSpPr>
+        <p:spPr/>
+      </p:sp>
+      <p:sp>
+        <p:nvSpPr>
+          <p:cNvPr id="3" name="Notes Placeholder 2"/>
+          <p:cNvSpPr>
+            <a:spLocks noGrp="1"/>
+          </p:cNvSpPr>
+          <p:nvPr>
+            <p:ph type="body" idx="3" sz="quarter"/>
+          </p:nvPr>
+        </p:nvSpPr>
+        <p:spPr/>
+        <p:txBody>
+          <a:bodyPr/>
+          <a:lstStyle/>
+          <a:p>
+            <a:r>
+              <a:t>Evidence: Sources: evaluation/freihand_annotated_interventions_full/{paired_summary.csv,report.md}</a:t>
+            </a:r>
+          </a:p>
+          <a:p>
+            <a:r>
+              <a:t>Local project root: /data/xjiang390/projects/WiLoR</a:t>
+            </a:r>
+          </a:p>
+        </p:txBody>
+      </p:sp>
+      <p:sp>
+        <p:nvSpPr>
+          <p:cNvPr id="4" name="Slide Number Placeholder 3"/>
+          <p:cNvSpPr>
+            <a:spLocks noGrp="1"/>
+          </p:cNvSpPr>
+          <p:nvPr>
+            <p:ph type="sldNum" idx="5" sz="quarter"/>
+          </p:nvPr>
+        </p:nvSpPr>
+        <p:spPr/>
+      </p:sp>
+    </p:spTree>
+  </p:cSld>
+  <p:clrMapOvr>
+    <a:masterClrMapping/>
+  </p:clrMapOvr>
+</p:notes>
+</file>
+
+<file path=ppt/notesSlides/notesSlide14.xml><?xml version="1.0" encoding="utf-8"?>
+<p:notes xmlns:a="http://schemas.openxmlformats.org/drawingml/2006/main" xmlns:p="http://schemas.openxmlformats.org/presentationml/2006/main" xmlns:r="http://schemas.openxmlformats.org/officeDocument/2006/relationships">
+  <p:cSld>
+    <p:spTree>
+      <p:nvGrpSpPr>
+        <p:cNvPr id="1" name=""/>
+        <p:cNvGrpSpPr/>
+        <p:nvPr/>
+      </p:nvGrpSpPr>
+      <p:grpSpPr>
+        <a:xfrm>
+          <a:off x="0" y="0"/>
+          <a:ext cx="0" cy="0"/>
+          <a:chOff x="0" y="0"/>
+          <a:chExt cx="0" cy="0"/>
+        </a:xfrm>
+      </p:grpSpPr>
+      <p:sp>
+        <p:nvSpPr>
+          <p:cNvPr id="2" name="Slide Image Placeholder 1"/>
+          <p:cNvSpPr>
+            <a:spLocks noGrp="1"/>
+          </p:cNvSpPr>
+          <p:nvPr>
+            <p:ph type="sldImg" idx="2"/>
+          </p:nvPr>
+        </p:nvSpPr>
+        <p:spPr/>
+      </p:sp>
+      <p:sp>
+        <p:nvSpPr>
+          <p:cNvPr id="3" name="Notes Placeholder 2"/>
+          <p:cNvSpPr>
+            <a:spLocks noGrp="1"/>
+          </p:cNvSpPr>
+          <p:nvPr>
+            <p:ph type="body" idx="3" sz="quarter"/>
+          </p:nvPr>
+        </p:nvSpPr>
+        <p:spPr/>
+        <p:txBody>
+          <a:bodyPr/>
+          <a:lstStyle/>
+          <a:p>
+            <a:r>
+              <a:t>Evidence: Sources: evaluation/freihand_loss_gradient_audit/{summary.csv,report.md,provenance.json}</a:t>
+            </a:r>
+          </a:p>
+          <a:p>
+            <a:r>
+              <a:t>Local project root: /data/xjiang390/projects/WiLoR</a:t>
+            </a:r>
+          </a:p>
+        </p:txBody>
+      </p:sp>
+      <p:sp>
+        <p:nvSpPr>
+          <p:cNvPr id="4" name="Slide Number Placeholder 3"/>
+          <p:cNvSpPr>
+            <a:spLocks noGrp="1"/>
+          </p:cNvSpPr>
+          <p:nvPr>
+            <p:ph type="sldNum" idx="5" sz="quarter"/>
+          </p:nvPr>
+        </p:nvSpPr>
+        <p:spPr/>
+      </p:sp>
+    </p:spTree>
+  </p:cSld>
+  <p:clrMapOvr>
+    <a:masterClrMapping/>
+  </p:clrMapOvr>
+</p:notes>
+</file>
+
+<file path=ppt/notesSlides/notesSlide15.xml><?xml version="1.0" encoding="utf-8"?>
+<p:notes xmlns:a="http://schemas.openxmlformats.org/drawingml/2006/main" xmlns:p="http://schemas.openxmlformats.org/presentationml/2006/main" xmlns:r="http://schemas.openxmlformats.org/officeDocument/2006/relationships">
+  <p:cSld>
+    <p:spTree>
+      <p:nvGrpSpPr>
+        <p:cNvPr id="1" name=""/>
+        <p:cNvGrpSpPr/>
+        <p:nvPr/>
+      </p:nvGrpSpPr>
+      <p:grpSpPr>
+        <a:xfrm>
+          <a:off x="0" y="0"/>
+          <a:ext cx="0" cy="0"/>
+          <a:chOff x="0" y="0"/>
+          <a:chExt cx="0" cy="0"/>
+        </a:xfrm>
+      </p:grpSpPr>
+      <p:sp>
+        <p:nvSpPr>
+          <p:cNvPr id="2" name="Slide Image Placeholder 1"/>
+          <p:cNvSpPr>
+            <a:spLocks noGrp="1"/>
+          </p:cNvSpPr>
+          <p:nvPr>
+            <p:ph type="sldImg" idx="2"/>
+          </p:nvPr>
+        </p:nvSpPr>
+        <p:spPr/>
+      </p:sp>
+      <p:sp>
+        <p:nvSpPr>
+          <p:cNvPr id="3" name="Notes Placeholder 2"/>
+          <p:cNvSpPr>
+            <a:spLocks noGrp="1"/>
+          </p:cNvSpPr>
+          <p:nvPr>
+            <p:ph type="body" idx="3" sz="quarter"/>
+          </p:nvPr>
+        </p:nvSpPr>
+        <p:spPr/>
+        <p:txBody>
+          <a:bodyPr/>
+          <a:lstStyle/>
+          <a:p>
+            <a:r>
+              <a:t>Evidence: Sources: full annotated intervention and loss-gradient audit; proposed experiment, not yet run</a:t>
+            </a:r>
+          </a:p>
+          <a:p>
+            <a:r>
+              <a:t>Local project root: /data/xjiang390/projects/WiLoR</a:t>
+            </a:r>
+          </a:p>
+        </p:txBody>
+      </p:sp>
+      <p:sp>
+        <p:nvSpPr>
+          <p:cNvPr id="4" name="Slide Number Placeholder 3"/>
+          <p:cNvSpPr>
+            <a:spLocks noGrp="1"/>
+          </p:cNvSpPr>
+          <p:nvPr>
+            <p:ph type="sldNum" idx="5" sz="quarter"/>
+          </p:nvPr>
+        </p:nvSpPr>
+        <p:spPr/>
+      </p:sp>
+    </p:spTree>
+  </p:cSld>
+  <p:clrMapOvr>
+    <a:masterClrMapping/>
+  </p:clrMapOvr>
+</p:notes>
+</file>
+
+<file path=ppt/notesSlides/notesSlide16.xml><?xml version="1.0" encoding="utf-8"?>
+<p:notes xmlns:a="http://schemas.openxmlformats.org/drawingml/2006/main" xmlns:p="http://schemas.openxmlformats.org/presentationml/2006/main" xmlns:r="http://schemas.openxmlformats.org/officeDocument/2006/relationships">
+  <p:cSld>
+    <p:spTree>
+      <p:nvGrpSpPr>
+        <p:cNvPr id="1" name=""/>
+        <p:cNvGrpSpPr/>
+        <p:nvPr/>
+      </p:nvGrpSpPr>
+      <p:grpSpPr>
+        <a:xfrm>
+          <a:off x="0" y="0"/>
+          <a:ext cx="0" cy="0"/>
+          <a:chOff x="0" y="0"/>
+          <a:chExt cx="0" cy="0"/>
+        </a:xfrm>
+      </p:grpSpPr>
+      <p:sp>
+        <p:nvSpPr>
+          <p:cNvPr id="2" name="Slide Image Placeholder 1"/>
+          <p:cNvSpPr>
+            <a:spLocks noGrp="1"/>
+          </p:cNvSpPr>
+          <p:nvPr>
+            <p:ph type="sldImg" idx="2"/>
+          </p:nvPr>
+        </p:nvSpPr>
+        <p:spPr/>
+      </p:sp>
+      <p:sp>
+        <p:nvSpPr>
+          <p:cNvPr id="3" name="Notes Placeholder 2"/>
+          <p:cNvSpPr>
+            <a:spLocks noGrp="1"/>
+          </p:cNvSpPr>
+          <p:nvPr>
+            <p:ph type="body" idx="3" sz="quarter"/>
+          </p:nvPr>
+        </p:nvSpPr>
+        <p:spPr/>
+        <p:txBody>
+          <a:bodyPr/>
+          <a:lstStyle/>
+          <a:p>
+            <a:r>
+              <a:t>Evidence: Sources: full annotated intervention, loss-gradient audit and all local scale_diagnostic reports</a:t>
             </a:r>
           </a:p>
           <a:p>
@@ -963,7 +1267,7 @@
           <a:lstStyle/>
           <a:p>
             <a:r>
-              <a:t>Evidence: Source: evaluation/freihand_full_comparison/metrics.csv; scripts/evaluate_freihand.py</a:t>
+              <a:t>Evidence: Source: evaluation/freihand_full_comparison_corrected/metrics.csv; projection_audit/report.md</a:t>
             </a:r>
           </a:p>
           <a:p>
@@ -4602,7 +4906,7 @@
               </a:defRPr>
             </a:pPr>
             <a:r>
-              <a:t>Fixed-input experiments implicate camera prediction and global orientation.</a:t>
+              <a:t>Full annotation interventions identify pose—especially finger articulation—as the main in-domain gap.</a:t>
             </a:r>
           </a:p>
           <a:p>
@@ -4618,7 +4922,7 @@
               </a:defRPr>
             </a:pPr>
             <a:r>
-              <a:t>Refinement usually compensates for the discrepancy; betas alone do not explain it.</a:t>
+              <a:t>The apparent demo shrinkage is not a systematic FreiHAND scale bias; camera and geometry are co-adapted.</a:t>
             </a:r>
           </a:p>
         </p:txBody>
@@ -4657,7 +4961,7 @@
               </a:defRPr>
             </a:pPr>
             <a:r>
-              <a:t>Evidence: 10,240 validation samples + 45 fixed hand proposals from 8 demo images.</a:t>
+              <a:t>Evidence: 10,240 annotated validation samples + 45 fixed hand proposals from 8 demo images.</a:t>
             </a:r>
           </a:p>
         </p:txBody>
@@ -4722,7 +5026,7 @@
               </a:defRPr>
             </a:pPr>
             <a:r>
-              <a:t>Pose swap: global orientation is a useful lead</a:t>
+              <a:t>Demo pose swap raised an orientation lead</a:t>
             </a:r>
           </a:p>
         </p:txBody>
@@ -5290,7 +5594,7 @@
               <a:spcAft>
                 <a:spcPts val="1200"/>
               </a:spcAft>
-              <a:defRPr sz="2100" b="0">
+              <a:defRPr sz="1900" b="0">
                 <a:solidFill>
                   <a:srgbClr val="007F86"/>
                 </a:solidFill>
@@ -5298,7 +5602,7 @@
               </a:defRPr>
             </a:pPr>
             <a:r>
-              <a:t>Orientation-only replacement brings the paired median extent ratio to 98.76%.</a:t>
+              <a:t>Orientation-only replacement brings the paired median extent ratio to 98.76% of official.</a:t>
             </a:r>
           </a:p>
           <a:p>
@@ -5306,7 +5610,7 @@
               <a:spcAft>
                 <a:spcPts val="1200"/>
               </a:spcAft>
-              <a:defRPr sz="2100" b="0">
+              <a:defRPr sz="1900" b="0">
                 <a:solidFill>
                   <a:srgbClr val="007F86"/>
                 </a:solidFill>
@@ -5314,7 +5618,7 @@
               </a:defRPr>
             </a:pPr>
             <a:r>
-              <a:t>Finger replacement does not consistently enlarge the projection.</a:t>
+              <a:t>This measures agreement with another model, not ground truth. Full annotated results show finger pose is the clearer accuracy limitation.</a:t>
             </a:r>
           </a:p>
           <a:p>
@@ -5322,7 +5626,7 @@
               <a:spcAft>
                 <a:spcPts val="1200"/>
               </a:spcAft>
-              <a:defRPr sz="2100" b="0">
+              <a:defRPr sz="1900" b="0">
                 <a:solidFill>
                   <a:srgbClr val="007F86"/>
                 </a:solidFill>
@@ -5742,7 +6046,7 @@
               </a:defRPr>
             </a:pPr>
             <a:r>
-              <a:t>Conclusions and the next decision</a:t>
+              <a:t>Full annotated intervention: absolute metrics</a:t>
             </a:r>
           </a:p>
         </p:txBody>
@@ -5781,7 +6085,7 @@
               </a:defRPr>
             </a:pPr>
             <a:r>
-              <a:t>Evidence supports targeted diagnosis before another training run.</a:t>
+              <a:t>All 10,240 deterministic local validation samples; the 512-sample pilot conclusion holds.</a:t>
             </a:r>
           </a:p>
         </p:txBody>
@@ -5820,7 +6124,7 @@
               </a:defRPr>
             </a:pPr>
             <a:r>
-              <a:t>Sources: all local scale_diagnostic reports; next steps are proposed, not completed</a:t>
+              <a:t>Sources: evaluation/freihand_annotated_interventions_full/{summary.csv,provenance.json}</a:t>
             </a:r>
           </a:p>
         </p:txBody>
@@ -5874,7 +6178,3390 @@
         </p:nvGraphicFramePr>
         <p:xfrm>
           <a:off x="502920" y="1645920"/>
-          <a:ext cx="11155680" cy="2423160"/>
+          <a:ext cx="11155680" cy="3200400"/>
+        </p:xfrm>
+        <a:graphic>
+          <a:graphicData uri="http://schemas.openxmlformats.org/drawingml/2006/table">
+            <a:tbl>
+              <a:tblPr firstRow="1" bandRow="1">
+                <a:tableStyleId>{5C22544A-7EE6-4342-B048-85BDC9FD1C3A}</a:tableStyleId>
+              </a:tblPr>
+              <a:tblGrid>
+                <a:gridCol w="1859280"/>
+                <a:gridCol w="1859280"/>
+                <a:gridCol w="1859280"/>
+                <a:gridCol w="1859280"/>
+                <a:gridCol w="1859280"/>
+                <a:gridCol w="1859280"/>
+              </a:tblGrid>
+              <a:tr h="533400">
+                <a:tc>
+                  <a:txBody>
+                    <a:bodyPr/>
+                    <a:lstStyle/>
+                    <a:p>
+                      <a:pPr>
+                        <a:defRPr sz="1600" b="1">
+                          <a:solidFill>
+                            <a:srgbClr val="FFFFFF"/>
+                          </a:solidFill>
+                          <a:latin typeface="Aptos"/>
+                        </a:defRPr>
+                      </a:pPr>
+                      <a:r>
+                        <a:t>Variant</a:t>
+                      </a:r>
+                    </a:p>
+                  </a:txBody>
+                  <a:tcPr marL="109728" marT="109728">
+                    <a:solidFill>
+                      <a:srgbClr val="17243A"/>
+                    </a:solidFill>
+                  </a:tcPr>
+                </a:tc>
+                <a:tc>
+                  <a:txBody>
+                    <a:bodyPr/>
+                    <a:lstStyle/>
+                    <a:p>
+                      <a:pPr>
+                        <a:defRPr sz="1600" b="1">
+                          <a:solidFill>
+                            <a:srgbClr val="FFFFFF"/>
+                          </a:solidFill>
+                          <a:latin typeface="Aptos"/>
+                        </a:defRPr>
+                      </a:pPr>
+                      <a:r>
+                        <a:t>Reproj px</a:t>
+                      </a:r>
+                    </a:p>
+                  </a:txBody>
+                  <a:tcPr marL="109728" marT="109728">
+                    <a:solidFill>
+                      <a:srgbClr val="17243A"/>
+                    </a:solidFill>
+                  </a:tcPr>
+                </a:tc>
+                <a:tc>
+                  <a:txBody>
+                    <a:bodyPr/>
+                    <a:lstStyle/>
+                    <a:p>
+                      <a:pPr>
+                        <a:defRPr sz="1600" b="1">
+                          <a:solidFill>
+                            <a:srgbClr val="FFFFFF"/>
+                          </a:solidFill>
+                          <a:latin typeface="Aptos"/>
+                        </a:defRPr>
+                      </a:pPr>
+                      <a:r>
+                        <a:t>MPJPE mm</a:t>
+                      </a:r>
+                    </a:p>
+                  </a:txBody>
+                  <a:tcPr marL="109728" marT="109728">
+                    <a:solidFill>
+                      <a:srgbClr val="17243A"/>
+                    </a:solidFill>
+                  </a:tcPr>
+                </a:tc>
+                <a:tc>
+                  <a:txBody>
+                    <a:bodyPr/>
+                    <a:lstStyle/>
+                    <a:p>
+                      <a:pPr>
+                        <a:defRPr sz="1600" b="1">
+                          <a:solidFill>
+                            <a:srgbClr val="FFFFFF"/>
+                          </a:solidFill>
+                          <a:latin typeface="Aptos"/>
+                        </a:defRPr>
+                      </a:pPr>
+                      <a:r>
+                        <a:t>PA-MPJPE</a:t>
+                      </a:r>
+                    </a:p>
+                  </a:txBody>
+                  <a:tcPr marL="109728" marT="109728">
+                    <a:solidFill>
+                      <a:srgbClr val="17243A"/>
+                    </a:solidFill>
+                  </a:tcPr>
+                </a:tc>
+                <a:tc>
+                  <a:txBody>
+                    <a:bodyPr/>
+                    <a:lstStyle/>
+                    <a:p>
+                      <a:pPr>
+                        <a:defRPr sz="1600" b="1">
+                          <a:solidFill>
+                            <a:srgbClr val="FFFFFF"/>
+                          </a:solidFill>
+                          <a:latin typeface="Aptos"/>
+                        </a:defRPr>
+                      </a:pPr>
+                      <a:r>
+                        <a:t>PVE mm</a:t>
+                      </a:r>
+                    </a:p>
+                  </a:txBody>
+                  <a:tcPr marL="109728" marT="109728">
+                    <a:solidFill>
+                      <a:srgbClr val="17243A"/>
+                    </a:solidFill>
+                  </a:tcPr>
+                </a:tc>
+                <a:tc>
+                  <a:txBody>
+                    <a:bodyPr/>
+                    <a:lstStyle/>
+                    <a:p>
+                      <a:pPr>
+                        <a:defRPr sz="1600" b="1">
+                          <a:solidFill>
+                            <a:srgbClr val="FFFFFF"/>
+                          </a:solidFill>
+                          <a:latin typeface="Aptos"/>
+                        </a:defRPr>
+                      </a:pPr>
+                      <a:r>
+                        <a:t>Extent / GT</a:t>
+                      </a:r>
+                    </a:p>
+                  </a:txBody>
+                  <a:tcPr marL="109728" marT="109728">
+                    <a:solidFill>
+                      <a:srgbClr val="17243A"/>
+                    </a:solidFill>
+                  </a:tcPr>
+                </a:tc>
+              </a:tr>
+              <a:tr h="533400">
+                <a:tc>
+                  <a:txBody>
+                    <a:bodyPr/>
+                    <a:lstStyle/>
+                    <a:p>
+                      <a:pPr>
+                        <a:defRPr sz="1600" b="0">
+                          <a:solidFill>
+                            <a:srgbClr val="17243A"/>
+                          </a:solidFill>
+                          <a:latin typeface="Aptos"/>
+                        </a:defRPr>
+                      </a:pPr>
+                      <a:r>
+                        <a:t>Self-trained</a:t>
+                      </a:r>
+                    </a:p>
+                  </a:txBody>
+                  <a:tcPr marL="109728" marT="109728">
+                    <a:solidFill>
+                      <a:srgbClr val="FFFFFF"/>
+                    </a:solidFill>
+                  </a:tcPr>
+                </a:tc>
+                <a:tc>
+                  <a:txBody>
+                    <a:bodyPr/>
+                    <a:lstStyle/>
+                    <a:p>
+                      <a:pPr>
+                        <a:defRPr sz="1600" b="0">
+                          <a:solidFill>
+                            <a:srgbClr val="17243A"/>
+                          </a:solidFill>
+                          <a:latin typeface="Aptos"/>
+                        </a:defRPr>
+                      </a:pPr>
+                      <a:r>
+                        <a:t>5.403</a:t>
+                      </a:r>
+                    </a:p>
+                  </a:txBody>
+                  <a:tcPr marL="109728" marT="109728">
+                    <a:solidFill>
+                      <a:srgbClr val="FFFFFF"/>
+                    </a:solidFill>
+                  </a:tcPr>
+                </a:tc>
+                <a:tc>
+                  <a:txBody>
+                    <a:bodyPr/>
+                    <a:lstStyle/>
+                    <a:p>
+                      <a:pPr>
+                        <a:defRPr sz="1600" b="0">
+                          <a:solidFill>
+                            <a:srgbClr val="17243A"/>
+                          </a:solidFill>
+                          <a:latin typeface="Aptos"/>
+                        </a:defRPr>
+                      </a:pPr>
+                      <a:r>
+                        <a:t>9.582</a:t>
+                      </a:r>
+                    </a:p>
+                  </a:txBody>
+                  <a:tcPr marL="109728" marT="109728">
+                    <a:solidFill>
+                      <a:srgbClr val="FFFFFF"/>
+                    </a:solidFill>
+                  </a:tcPr>
+                </a:tc>
+                <a:tc>
+                  <a:txBody>
+                    <a:bodyPr/>
+                    <a:lstStyle/>
+                    <a:p>
+                      <a:pPr>
+                        <a:defRPr sz="1600" b="0">
+                          <a:solidFill>
+                            <a:srgbClr val="17243A"/>
+                          </a:solidFill>
+                          <a:latin typeface="Aptos"/>
+                        </a:defRPr>
+                      </a:pPr>
+                      <a:r>
+                        <a:t>6.006</a:t>
+                      </a:r>
+                    </a:p>
+                  </a:txBody>
+                  <a:tcPr marL="109728" marT="109728">
+                    <a:solidFill>
+                      <a:srgbClr val="FFFFFF"/>
+                    </a:solidFill>
+                  </a:tcPr>
+                </a:tc>
+                <a:tc>
+                  <a:txBody>
+                    <a:bodyPr/>
+                    <a:lstStyle/>
+                    <a:p>
+                      <a:pPr>
+                        <a:defRPr sz="1600" b="0">
+                          <a:solidFill>
+                            <a:srgbClr val="17243A"/>
+                          </a:solidFill>
+                          <a:latin typeface="Aptos"/>
+                        </a:defRPr>
+                      </a:pPr>
+                      <a:r>
+                        <a:t>9.026</a:t>
+                      </a:r>
+                    </a:p>
+                  </a:txBody>
+                  <a:tcPr marL="109728" marT="109728">
+                    <a:solidFill>
+                      <a:srgbClr val="FFFFFF"/>
+                    </a:solidFill>
+                  </a:tcPr>
+                </a:tc>
+                <a:tc>
+                  <a:txBody>
+                    <a:bodyPr/>
+                    <a:lstStyle/>
+                    <a:p>
+                      <a:pPr>
+                        <a:defRPr sz="1600" b="0">
+                          <a:solidFill>
+                            <a:srgbClr val="17243A"/>
+                          </a:solidFill>
+                          <a:latin typeface="Aptos"/>
+                        </a:defRPr>
+                      </a:pPr>
+                      <a:r>
+                        <a:t>98.34%</a:t>
+                      </a:r>
+                    </a:p>
+                  </a:txBody>
+                  <a:tcPr marL="109728" marT="109728">
+                    <a:solidFill>
+                      <a:srgbClr val="FFFFFF"/>
+                    </a:solidFill>
+                  </a:tcPr>
+                </a:tc>
+              </a:tr>
+              <a:tr h="533400">
+                <a:tc>
+                  <a:txBody>
+                    <a:bodyPr/>
+                    <a:lstStyle/>
+                    <a:p>
+                      <a:pPr>
+                        <a:defRPr sz="1600" b="0">
+                          <a:solidFill>
+                            <a:srgbClr val="17243A"/>
+                          </a:solidFill>
+                          <a:latin typeface="Aptos"/>
+                        </a:defRPr>
+                      </a:pPr>
+                      <a:r>
+                        <a:t>Official WiLoR</a:t>
+                      </a:r>
+                    </a:p>
+                  </a:txBody>
+                  <a:tcPr marL="109728" marT="109728">
+                    <a:solidFill>
+                      <a:srgbClr val="E8EEF4"/>
+                    </a:solidFill>
+                  </a:tcPr>
+                </a:tc>
+                <a:tc>
+                  <a:txBody>
+                    <a:bodyPr/>
+                    <a:lstStyle/>
+                    <a:p>
+                      <a:pPr>
+                        <a:defRPr sz="1600" b="0">
+                          <a:solidFill>
+                            <a:srgbClr val="17243A"/>
+                          </a:solidFill>
+                          <a:latin typeface="Aptos"/>
+                        </a:defRPr>
+                      </a:pPr>
+                      <a:r>
+                        <a:t>2.678</a:t>
+                      </a:r>
+                    </a:p>
+                  </a:txBody>
+                  <a:tcPr marL="109728" marT="109728">
+                    <a:solidFill>
+                      <a:srgbClr val="E8EEF4"/>
+                    </a:solidFill>
+                  </a:tcPr>
+                </a:tc>
+                <a:tc>
+                  <a:txBody>
+                    <a:bodyPr/>
+                    <a:lstStyle/>
+                    <a:p>
+                      <a:pPr>
+                        <a:defRPr sz="1600" b="0">
+                          <a:solidFill>
+                            <a:srgbClr val="17243A"/>
+                          </a:solidFill>
+                          <a:latin typeface="Aptos"/>
+                        </a:defRPr>
+                      </a:pPr>
+                      <a:r>
+                        <a:t>4.192</a:t>
+                      </a:r>
+                    </a:p>
+                  </a:txBody>
+                  <a:tcPr marL="109728" marT="109728">
+                    <a:solidFill>
+                      <a:srgbClr val="E8EEF4"/>
+                    </a:solidFill>
+                  </a:tcPr>
+                </a:tc>
+                <a:tc>
+                  <a:txBody>
+                    <a:bodyPr/>
+                    <a:lstStyle/>
+                    <a:p>
+                      <a:pPr>
+                        <a:defRPr sz="1600" b="0">
+                          <a:solidFill>
+                            <a:srgbClr val="17243A"/>
+                          </a:solidFill>
+                          <a:latin typeface="Aptos"/>
+                        </a:defRPr>
+                      </a:pPr>
+                      <a:r>
+                        <a:t>3.349</a:t>
+                      </a:r>
+                    </a:p>
+                  </a:txBody>
+                  <a:tcPr marL="109728" marT="109728">
+                    <a:solidFill>
+                      <a:srgbClr val="E8EEF4"/>
+                    </a:solidFill>
+                  </a:tcPr>
+                </a:tc>
+                <a:tc>
+                  <a:txBody>
+                    <a:bodyPr/>
+                    <a:lstStyle/>
+                    <a:p>
+                      <a:pPr>
+                        <a:defRPr sz="1600" b="0">
+                          <a:solidFill>
+                            <a:srgbClr val="17243A"/>
+                          </a:solidFill>
+                          <a:latin typeface="Aptos"/>
+                        </a:defRPr>
+                      </a:pPr>
+                      <a:r>
+                        <a:t>4.098</a:t>
+                      </a:r>
+                    </a:p>
+                  </a:txBody>
+                  <a:tcPr marL="109728" marT="109728">
+                    <a:solidFill>
+                      <a:srgbClr val="E8EEF4"/>
+                    </a:solidFill>
+                  </a:tcPr>
+                </a:tc>
+                <a:tc>
+                  <a:txBody>
+                    <a:bodyPr/>
+                    <a:lstStyle/>
+                    <a:p>
+                      <a:pPr>
+                        <a:defRPr sz="1600" b="0">
+                          <a:solidFill>
+                            <a:srgbClr val="17243A"/>
+                          </a:solidFill>
+                          <a:latin typeface="Aptos"/>
+                        </a:defRPr>
+                      </a:pPr>
+                      <a:r>
+                        <a:t>99.13%</a:t>
+                      </a:r>
+                    </a:p>
+                  </a:txBody>
+                  <a:tcPr marL="109728" marT="109728">
+                    <a:solidFill>
+                      <a:srgbClr val="E8EEF4"/>
+                    </a:solidFill>
+                  </a:tcPr>
+                </a:tc>
+              </a:tr>
+              <a:tr h="533400">
+                <a:tc>
+                  <a:txBody>
+                    <a:bodyPr/>
+                    <a:lstStyle/>
+                    <a:p>
+                      <a:pPr>
+                        <a:defRPr sz="1600" b="0">
+                          <a:solidFill>
+                            <a:srgbClr val="17243A"/>
+                          </a:solidFill>
+                          <a:latin typeface="Aptos"/>
+                        </a:defRPr>
+                      </a:pPr>
+                      <a:r>
+                        <a:t>Trained + GT orientation</a:t>
+                      </a:r>
+                    </a:p>
+                  </a:txBody>
+                  <a:tcPr marL="109728" marT="109728">
+                    <a:solidFill>
+                      <a:srgbClr val="FFFFFF"/>
+                    </a:solidFill>
+                  </a:tcPr>
+                </a:tc>
+                <a:tc>
+                  <a:txBody>
+                    <a:bodyPr/>
+                    <a:lstStyle/>
+                    <a:p>
+                      <a:pPr>
+                        <a:defRPr sz="1600" b="0">
+                          <a:solidFill>
+                            <a:srgbClr val="17243A"/>
+                          </a:solidFill>
+                          <a:latin typeface="Aptos"/>
+                        </a:defRPr>
+                      </a:pPr>
+                      <a:r>
+                        <a:t>6.330</a:t>
+                      </a:r>
+                    </a:p>
+                  </a:txBody>
+                  <a:tcPr marL="109728" marT="109728">
+                    <a:solidFill>
+                      <a:srgbClr val="FFFFFF"/>
+                    </a:solidFill>
+                  </a:tcPr>
+                </a:tc>
+                <a:tc>
+                  <a:txBody>
+                    <a:bodyPr/>
+                    <a:lstStyle/>
+                    <a:p>
+                      <a:pPr>
+                        <a:defRPr sz="1600" b="0">
+                          <a:solidFill>
+                            <a:srgbClr val="17243A"/>
+                          </a:solidFill>
+                          <a:latin typeface="Aptos"/>
+                        </a:defRPr>
+                      </a:pPr>
+                      <a:r>
+                        <a:t>8.560</a:t>
+                      </a:r>
+                    </a:p>
+                  </a:txBody>
+                  <a:tcPr marL="109728" marT="109728">
+                    <a:solidFill>
+                      <a:srgbClr val="FFFFFF"/>
+                    </a:solidFill>
+                  </a:tcPr>
+                </a:tc>
+                <a:tc>
+                  <a:txBody>
+                    <a:bodyPr/>
+                    <a:lstStyle/>
+                    <a:p>
+                      <a:pPr>
+                        <a:defRPr sz="1600" b="0">
+                          <a:solidFill>
+                            <a:srgbClr val="17243A"/>
+                          </a:solidFill>
+                          <a:latin typeface="Aptos"/>
+                        </a:defRPr>
+                      </a:pPr>
+                      <a:r>
+                        <a:t>6.006</a:t>
+                      </a:r>
+                    </a:p>
+                  </a:txBody>
+                  <a:tcPr marL="109728" marT="109728">
+                    <a:solidFill>
+                      <a:srgbClr val="FFFFFF"/>
+                    </a:solidFill>
+                  </a:tcPr>
+                </a:tc>
+                <a:tc>
+                  <a:txBody>
+                    <a:bodyPr/>
+                    <a:lstStyle/>
+                    <a:p>
+                      <a:pPr>
+                        <a:defRPr sz="1600" b="0">
+                          <a:solidFill>
+                            <a:srgbClr val="17243A"/>
+                          </a:solidFill>
+                          <a:latin typeface="Aptos"/>
+                        </a:defRPr>
+                      </a:pPr>
+                      <a:r>
+                        <a:t>7.407</a:t>
+                      </a:r>
+                    </a:p>
+                  </a:txBody>
+                  <a:tcPr marL="109728" marT="109728">
+                    <a:solidFill>
+                      <a:srgbClr val="FFFFFF"/>
+                    </a:solidFill>
+                  </a:tcPr>
+                </a:tc>
+                <a:tc>
+                  <a:txBody>
+                    <a:bodyPr/>
+                    <a:lstStyle/>
+                    <a:p>
+                      <a:pPr>
+                        <a:defRPr sz="1600" b="0">
+                          <a:solidFill>
+                            <a:srgbClr val="17243A"/>
+                          </a:solidFill>
+                          <a:latin typeface="Aptos"/>
+                        </a:defRPr>
+                      </a:pPr>
+                      <a:r>
+                        <a:t>98.07%</a:t>
+                      </a:r>
+                    </a:p>
+                  </a:txBody>
+                  <a:tcPr marL="109728" marT="109728">
+                    <a:solidFill>
+                      <a:srgbClr val="FFFFFF"/>
+                    </a:solidFill>
+                  </a:tcPr>
+                </a:tc>
+              </a:tr>
+              <a:tr h="533400">
+                <a:tc>
+                  <a:txBody>
+                    <a:bodyPr/>
+                    <a:lstStyle/>
+                    <a:p>
+                      <a:pPr>
+                        <a:defRPr sz="1600" b="0">
+                          <a:solidFill>
+                            <a:srgbClr val="17243A"/>
+                          </a:solidFill>
+                          <a:latin typeface="Aptos"/>
+                        </a:defRPr>
+                      </a:pPr>
+                      <a:r>
+                        <a:t>Trained + GT fingers</a:t>
+                      </a:r>
+                    </a:p>
+                  </a:txBody>
+                  <a:tcPr marL="109728" marT="109728">
+                    <a:solidFill>
+                      <a:srgbClr val="E8EEF4"/>
+                    </a:solidFill>
+                  </a:tcPr>
+                </a:tc>
+                <a:tc>
+                  <a:txBody>
+                    <a:bodyPr/>
+                    <a:lstStyle/>
+                    <a:p>
+                      <a:pPr>
+                        <a:defRPr sz="1600" b="0">
+                          <a:solidFill>
+                            <a:srgbClr val="17243A"/>
+                          </a:solidFill>
+                          <a:latin typeface="Aptos"/>
+                        </a:defRPr>
+                      </a:pPr>
+                      <a:r>
+                        <a:t>5.211</a:t>
+                      </a:r>
+                    </a:p>
+                  </a:txBody>
+                  <a:tcPr marL="109728" marT="109728">
+                    <a:solidFill>
+                      <a:srgbClr val="E8EEF4"/>
+                    </a:solidFill>
+                  </a:tcPr>
+                </a:tc>
+                <a:tc>
+                  <a:txBody>
+                    <a:bodyPr/>
+                    <a:lstStyle/>
+                    <a:p>
+                      <a:pPr>
+                        <a:defRPr sz="1600" b="0">
+                          <a:solidFill>
+                            <a:srgbClr val="17243A"/>
+                          </a:solidFill>
+                          <a:latin typeface="Aptos"/>
+                        </a:defRPr>
+                      </a:pPr>
+                      <a:r>
+                        <a:t>8.448</a:t>
+                      </a:r>
+                    </a:p>
+                  </a:txBody>
+                  <a:tcPr marL="109728" marT="109728">
+                    <a:solidFill>
+                      <a:srgbClr val="E8EEF4"/>
+                    </a:solidFill>
+                  </a:tcPr>
+                </a:tc>
+                <a:tc>
+                  <a:txBody>
+                    <a:bodyPr/>
+                    <a:lstStyle/>
+                    <a:p>
+                      <a:pPr>
+                        <a:defRPr sz="1600" b="0">
+                          <a:solidFill>
+                            <a:srgbClr val="17243A"/>
+                          </a:solidFill>
+                          <a:latin typeface="Aptos"/>
+                        </a:defRPr>
+                      </a:pPr>
+                      <a:r>
+                        <a:t>3.018</a:t>
+                      </a:r>
+                    </a:p>
+                  </a:txBody>
+                  <a:tcPr marL="109728" marT="109728">
+                    <a:solidFill>
+                      <a:srgbClr val="E8EEF4"/>
+                    </a:solidFill>
+                  </a:tcPr>
+                </a:tc>
+                <a:tc>
+                  <a:txBody>
+                    <a:bodyPr/>
+                    <a:lstStyle/>
+                    <a:p>
+                      <a:pPr>
+                        <a:defRPr sz="1600" b="0">
+                          <a:solidFill>
+                            <a:srgbClr val="17243A"/>
+                          </a:solidFill>
+                          <a:latin typeface="Aptos"/>
+                        </a:defRPr>
+                      </a:pPr>
+                      <a:r>
+                        <a:t>7.914</a:t>
+                      </a:r>
+                    </a:p>
+                  </a:txBody>
+                  <a:tcPr marL="109728" marT="109728">
+                    <a:solidFill>
+                      <a:srgbClr val="E8EEF4"/>
+                    </a:solidFill>
+                  </a:tcPr>
+                </a:tc>
+                <a:tc>
+                  <a:txBody>
+                    <a:bodyPr/>
+                    <a:lstStyle/>
+                    <a:p>
+                      <a:pPr>
+                        <a:defRPr sz="1600" b="0">
+                          <a:solidFill>
+                            <a:srgbClr val="17243A"/>
+                          </a:solidFill>
+                          <a:latin typeface="Aptos"/>
+                        </a:defRPr>
+                      </a:pPr>
+                      <a:r>
+                        <a:t>97.06%</a:t>
+                      </a:r>
+                    </a:p>
+                  </a:txBody>
+                  <a:tcPr marL="109728" marT="109728">
+                    <a:solidFill>
+                      <a:srgbClr val="E8EEF4"/>
+                    </a:solidFill>
+                  </a:tcPr>
+                </a:tc>
+              </a:tr>
+              <a:tr h="533400">
+                <a:tc>
+                  <a:txBody>
+                    <a:bodyPr/>
+                    <a:lstStyle/>
+                    <a:p>
+                      <a:pPr>
+                        <a:defRPr sz="1600" b="0">
+                          <a:solidFill>
+                            <a:srgbClr val="17243A"/>
+                          </a:solidFill>
+                          <a:latin typeface="Aptos"/>
+                        </a:defRPr>
+                      </a:pPr>
+                      <a:r>
+                        <a:t>Trained + GT full pose</a:t>
+                      </a:r>
+                    </a:p>
+                  </a:txBody>
+                  <a:tcPr marL="109728" marT="109728">
+                    <a:solidFill>
+                      <a:srgbClr val="FFFFFF"/>
+                    </a:solidFill>
+                  </a:tcPr>
+                </a:tc>
+                <a:tc>
+                  <a:txBody>
+                    <a:bodyPr/>
+                    <a:lstStyle/>
+                    <a:p>
+                      <a:pPr>
+                        <a:defRPr sz="1600" b="0">
+                          <a:solidFill>
+                            <a:srgbClr val="17243A"/>
+                          </a:solidFill>
+                          <a:latin typeface="Aptos"/>
+                        </a:defRPr>
+                      </a:pPr>
+                      <a:r>
+                        <a:t>4.687</a:t>
+                      </a:r>
+                    </a:p>
+                  </a:txBody>
+                  <a:tcPr marL="109728" marT="109728">
+                    <a:solidFill>
+                      <a:srgbClr val="FFFFFF"/>
+                    </a:solidFill>
+                  </a:tcPr>
+                </a:tc>
+                <a:tc>
+                  <a:txBody>
+                    <a:bodyPr/>
+                    <a:lstStyle/>
+                    <a:p>
+                      <a:pPr>
+                        <a:defRPr sz="1600" b="0">
+                          <a:solidFill>
+                            <a:srgbClr val="17243A"/>
+                          </a:solidFill>
+                          <a:latin typeface="Aptos"/>
+                        </a:defRPr>
+                      </a:pPr>
+                      <a:r>
+                        <a:t>4.420</a:t>
+                      </a:r>
+                    </a:p>
+                  </a:txBody>
+                  <a:tcPr marL="109728" marT="109728">
+                    <a:solidFill>
+                      <a:srgbClr val="FFFFFF"/>
+                    </a:solidFill>
+                  </a:tcPr>
+                </a:tc>
+                <a:tc>
+                  <a:txBody>
+                    <a:bodyPr/>
+                    <a:lstStyle/>
+                    <a:p>
+                      <a:pPr>
+                        <a:defRPr sz="1600" b="0">
+                          <a:solidFill>
+                            <a:srgbClr val="17243A"/>
+                          </a:solidFill>
+                          <a:latin typeface="Aptos"/>
+                        </a:defRPr>
+                      </a:pPr>
+                      <a:r>
+                        <a:t>3.018</a:t>
+                      </a:r>
+                    </a:p>
+                  </a:txBody>
+                  <a:tcPr marL="109728" marT="109728">
+                    <a:solidFill>
+                      <a:srgbClr val="FFFFFF"/>
+                    </a:solidFill>
+                  </a:tcPr>
+                </a:tc>
+                <a:tc>
+                  <a:txBody>
+                    <a:bodyPr/>
+                    <a:lstStyle/>
+                    <a:p>
+                      <a:pPr>
+                        <a:defRPr sz="1600" b="0">
+                          <a:solidFill>
+                            <a:srgbClr val="17243A"/>
+                          </a:solidFill>
+                          <a:latin typeface="Aptos"/>
+                        </a:defRPr>
+                      </a:pPr>
+                      <a:r>
+                        <a:t>3.057</a:t>
+                      </a:r>
+                    </a:p>
+                  </a:txBody>
+                  <a:tcPr marL="109728" marT="109728">
+                    <a:solidFill>
+                      <a:srgbClr val="FFFFFF"/>
+                    </a:solidFill>
+                  </a:tcPr>
+                </a:tc>
+                <a:tc>
+                  <a:txBody>
+                    <a:bodyPr/>
+                    <a:lstStyle/>
+                    <a:p>
+                      <a:pPr>
+                        <a:defRPr sz="1600" b="0">
+                          <a:solidFill>
+                            <a:srgbClr val="17243A"/>
+                          </a:solidFill>
+                          <a:latin typeface="Aptos"/>
+                        </a:defRPr>
+                      </a:pPr>
+                      <a:r>
+                        <a:t>96.75%</a:t>
+                      </a:r>
+                    </a:p>
+                  </a:txBody>
+                  <a:tcPr marL="109728" marT="109728">
+                    <a:solidFill>
+                      <a:srgbClr val="FFFFFF"/>
+                    </a:solidFill>
+                  </a:tcPr>
+                </a:tc>
+              </a:tr>
+            </a:tbl>
+          </a:graphicData>
+        </a:graphic>
+      </p:graphicFrame>
+      <p:sp>
+        <p:nvSpPr>
+          <p:cNvPr id="7" name="TextBox 6"/>
+          <p:cNvSpPr txBox="1"/>
+          <p:nvPr/>
+        </p:nvSpPr>
+        <p:spPr>
+          <a:xfrm>
+            <a:off x="594360" y="5257800"/>
+            <a:ext cx="10972800" cy="914400"/>
+          </a:xfrm>
+          <a:prstGeom prst="rect">
+            <a:avLst/>
+          </a:prstGeom>
+          <a:noFill/>
+        </p:spPr>
+        <p:txBody>
+          <a:bodyPr wrap="square">
+            <a:spAutoFit/>
+          </a:bodyPr>
+          <a:lstStyle/>
+          <a:p>
+            <a:pPr>
+              <a:spcAft>
+                <a:spcPts val="1200"/>
+              </a:spcAft>
+              <a:defRPr sz="1900" b="0">
+                <a:solidFill>
+                  <a:srgbClr val="007F86"/>
+                </a:solidFill>
+                <a:latin typeface="Aptos"/>
+              </a:defRPr>
+            </a:pPr>
+            <a:r>
+              <a:t>Self-trained extent is 98.34% of GT: no strong systematic in-domain shrinkage.</a:t>
+            </a:r>
+          </a:p>
+          <a:p>
+            <a:pPr>
+              <a:spcAft>
+                <a:spcPts val="1200"/>
+              </a:spcAft>
+              <a:defRPr sz="1900" b="0">
+                <a:solidFill>
+                  <a:srgbClr val="007F86"/>
+                </a:solidFill>
+                <a:latin typeface="Aptos"/>
+              </a:defRPr>
+            </a:pPr>
+            <a:r>
+              <a:t>Official WiLoR is still substantially more accurate across all four error metrics.</a:t>
+            </a:r>
+          </a:p>
+        </p:txBody>
+      </p:sp>
+    </p:spTree>
+  </p:cSld>
+  <p:clrMapOvr>
+    <a:masterClrMapping/>
+  </p:clrMapOvr>
+</p:sld>
+</file>
+
+<file path=ppt/slides/slide13.xml><?xml version="1.0" encoding="utf-8"?>
+<p:sld xmlns:a="http://schemas.openxmlformats.org/drawingml/2006/main" xmlns:p="http://schemas.openxmlformats.org/presentationml/2006/main" xmlns:r="http://schemas.openxmlformats.org/officeDocument/2006/relationships">
+  <p:cSld>
+    <p:bg>
+      <p:bgPr>
+        <a:solidFill>
+          <a:srgbClr val="F4F6FA"/>
+        </a:solidFill>
+        <a:effectLst/>
+      </p:bgPr>
+    </p:bg>
+    <p:spTree>
+      <p:nvGrpSpPr>
+        <p:cNvPr id="1" name=""/>
+        <p:cNvGrpSpPr/>
+        <p:nvPr/>
+      </p:nvGrpSpPr>
+      <p:grpSpPr/>
+      <p:sp>
+        <p:nvSpPr>
+          <p:cNvPr id="2" name="TextBox 1"/>
+          <p:cNvSpPr txBox="1"/>
+          <p:nvPr/>
+        </p:nvSpPr>
+        <p:spPr>
+          <a:xfrm>
+            <a:off x="457200" y="201168"/>
+            <a:ext cx="11247120" cy="548640"/>
+          </a:xfrm>
+          <a:prstGeom prst="rect">
+            <a:avLst/>
+          </a:prstGeom>
+          <a:noFill/>
+        </p:spPr>
+        <p:txBody>
+          <a:bodyPr wrap="square">
+            <a:spAutoFit/>
+          </a:bodyPr>
+          <a:lstStyle/>
+          <a:p>
+            <a:pPr>
+              <a:spcAft>
+                <a:spcPts val="1200"/>
+              </a:spcAft>
+              <a:defRPr sz="2800" b="1">
+                <a:solidFill>
+                  <a:srgbClr val="17243A"/>
+                </a:solidFill>
+                <a:latin typeface="Aptos"/>
+              </a:defRPr>
+            </a:pPr>
+            <a:r>
+              <a:t>Full annotated intervention: paired evidence</a:t>
+            </a:r>
+          </a:p>
+        </p:txBody>
+      </p:sp>
+      <p:sp>
+        <p:nvSpPr>
+          <p:cNvPr id="3" name="TextBox 2"/>
+          <p:cNvSpPr txBox="1"/>
+          <p:nvPr/>
+        </p:nvSpPr>
+        <p:spPr>
+          <a:xfrm>
+            <a:off x="457200" y="868680"/>
+            <a:ext cx="11247120" cy="502920"/>
+          </a:xfrm>
+          <a:prstGeom prst="rect">
+            <a:avLst/>
+          </a:prstGeom>
+          <a:noFill/>
+        </p:spPr>
+        <p:txBody>
+          <a:bodyPr wrap="square">
+            <a:spAutoFit/>
+          </a:bodyPr>
+          <a:lstStyle/>
+          <a:p>
+            <a:pPr>
+              <a:spcAft>
+                <a:spcPts val="1200"/>
+              </a:spcAft>
+              <a:defRPr sz="1500" b="0">
+                <a:solidFill>
+                  <a:srgbClr val="58677B"/>
+                </a:solidFill>
+                <a:latin typeface="Aptos"/>
+              </a:defRPr>
+            </a:pPr>
+            <a:r>
+              <a:t>Interventions are diagnostic counterfactuals; lower errors are better.</a:t>
+            </a:r>
+          </a:p>
+        </p:txBody>
+      </p:sp>
+      <p:sp>
+        <p:nvSpPr>
+          <p:cNvPr id="4" name="TextBox 3"/>
+          <p:cNvSpPr txBox="1"/>
+          <p:nvPr/>
+        </p:nvSpPr>
+        <p:spPr>
+          <a:xfrm>
+            <a:off x="457200" y="6473952"/>
+            <a:ext cx="10881360" cy="228600"/>
+          </a:xfrm>
+          <a:prstGeom prst="rect">
+            <a:avLst/>
+          </a:prstGeom>
+          <a:noFill/>
+        </p:spPr>
+        <p:txBody>
+          <a:bodyPr wrap="square">
+            <a:spAutoFit/>
+          </a:bodyPr>
+          <a:lstStyle/>
+          <a:p>
+            <a:pPr>
+              <a:spcAft>
+                <a:spcPts val="1200"/>
+              </a:spcAft>
+              <a:defRPr sz="900" b="0">
+                <a:solidFill>
+                  <a:srgbClr val="58677B"/>
+                </a:solidFill>
+                <a:latin typeface="Aptos"/>
+              </a:defRPr>
+            </a:pPr>
+            <a:r>
+              <a:t>Sources: evaluation/freihand_annotated_interventions_full/{paired_summary.csv,report.md}</a:t>
+            </a:r>
+          </a:p>
+        </p:txBody>
+      </p:sp>
+      <p:sp>
+        <p:nvSpPr>
+          <p:cNvPr id="5" name="TextBox 4"/>
+          <p:cNvSpPr txBox="1"/>
+          <p:nvPr/>
+        </p:nvSpPr>
+        <p:spPr>
+          <a:xfrm>
+            <a:off x="11292840" y="6437376"/>
+            <a:ext cx="457200" cy="274320"/>
+          </a:xfrm>
+          <a:prstGeom prst="rect">
+            <a:avLst/>
+          </a:prstGeom>
+          <a:noFill/>
+        </p:spPr>
+        <p:txBody>
+          <a:bodyPr wrap="square">
+            <a:spAutoFit/>
+          </a:bodyPr>
+          <a:lstStyle/>
+          <a:p>
+            <a:pPr>
+              <a:spcAft>
+                <a:spcPts val="1200"/>
+              </a:spcAft>
+              <a:defRPr sz="1100" b="0">
+                <a:solidFill>
+                  <a:srgbClr val="58677B"/>
+                </a:solidFill>
+                <a:latin typeface="Aptos"/>
+              </a:defRPr>
+            </a:pPr>
+            <a:r>
+              <a:t>13</a:t>
+            </a:r>
+          </a:p>
+        </p:txBody>
+      </p:sp>
+      <p:graphicFrame>
+        <p:nvGraphicFramePr>
+          <p:cNvPr id="6" name="Table 5"/>
+          <p:cNvGraphicFramePr>
+            <a:graphicFrameLocks noGrp="1"/>
+          </p:cNvGraphicFramePr>
+          <p:nvPr/>
+        </p:nvGraphicFramePr>
+        <p:xfrm>
+          <a:off x="502920" y="1645920"/>
+          <a:ext cx="11155680" cy="3246120"/>
+        </p:xfrm>
+        <a:graphic>
+          <a:graphicData uri="http://schemas.openxmlformats.org/drawingml/2006/table">
+            <a:tbl>
+              <a:tblPr firstRow="1" bandRow="1">
+                <a:tableStyleId>{5C22544A-7EE6-4342-B048-85BDC9FD1C3A}</a:tableStyleId>
+              </a:tblPr>
+              <a:tblGrid>
+                <a:gridCol w="3718560"/>
+                <a:gridCol w="3718560"/>
+                <a:gridCol w="3718560"/>
+              </a:tblGrid>
+              <a:tr h="463731">
+                <a:tc>
+                  <a:txBody>
+                    <a:bodyPr/>
+                    <a:lstStyle/>
+                    <a:p>
+                      <a:pPr>
+                        <a:defRPr sz="1600" b="1">
+                          <a:solidFill>
+                            <a:srgbClr val="FFFFFF"/>
+                          </a:solidFill>
+                          <a:latin typeface="Aptos"/>
+                        </a:defRPr>
+                      </a:pPr>
+                      <a:r>
+                        <a:t>Paired comparison</a:t>
+                      </a:r>
+                    </a:p>
+                  </a:txBody>
+                  <a:tcPr marL="109728" marT="109728">
+                    <a:solidFill>
+                      <a:srgbClr val="17243A"/>
+                    </a:solidFill>
+                  </a:tcPr>
+                </a:tc>
+                <a:tc>
+                  <a:txBody>
+                    <a:bodyPr/>
+                    <a:lstStyle/>
+                    <a:p>
+                      <a:pPr>
+                        <a:defRPr sz="1600" b="1">
+                          <a:solidFill>
+                            <a:srgbClr val="FFFFFF"/>
+                          </a:solidFill>
+                          <a:latin typeface="Aptos"/>
+                        </a:defRPr>
+                      </a:pPr>
+                      <a:r>
+                        <a:t>Improved samples</a:t>
+                      </a:r>
+                    </a:p>
+                  </a:txBody>
+                  <a:tcPr marL="109728" marT="109728">
+                    <a:solidFill>
+                      <a:srgbClr val="17243A"/>
+                    </a:solidFill>
+                  </a:tcPr>
+                </a:tc>
+                <a:tc>
+                  <a:txBody>
+                    <a:bodyPr/>
+                    <a:lstStyle/>
+                    <a:p>
+                      <a:pPr>
+                        <a:defRPr sz="1600" b="1">
+                          <a:solidFill>
+                            <a:srgbClr val="FFFFFF"/>
+                          </a:solidFill>
+                          <a:latin typeface="Aptos"/>
+                        </a:defRPr>
+                      </a:pPr>
+                      <a:r>
+                        <a:t>Median relative change</a:t>
+                      </a:r>
+                    </a:p>
+                  </a:txBody>
+                  <a:tcPr marL="109728" marT="109728">
+                    <a:solidFill>
+                      <a:srgbClr val="17243A"/>
+                    </a:solidFill>
+                  </a:tcPr>
+                </a:tc>
+              </a:tr>
+              <a:tr h="463731">
+                <a:tc>
+                  <a:txBody>
+                    <a:bodyPr/>
+                    <a:lstStyle/>
+                    <a:p>
+                      <a:pPr>
+                        <a:defRPr sz="1600" b="0">
+                          <a:solidFill>
+                            <a:srgbClr val="17243A"/>
+                          </a:solidFill>
+                          <a:latin typeface="Aptos"/>
+                        </a:defRPr>
+                      </a:pPr>
+                      <a:r>
+                        <a:t>Official vs trained: reprojection</a:t>
+                      </a:r>
+                    </a:p>
+                  </a:txBody>
+                  <a:tcPr marL="109728" marT="109728">
+                    <a:solidFill>
+                      <a:srgbClr val="FFFFFF"/>
+                    </a:solidFill>
+                  </a:tcPr>
+                </a:tc>
+                <a:tc>
+                  <a:txBody>
+                    <a:bodyPr/>
+                    <a:lstStyle/>
+                    <a:p>
+                      <a:pPr>
+                        <a:defRPr sz="1600" b="0">
+                          <a:solidFill>
+                            <a:srgbClr val="17243A"/>
+                          </a:solidFill>
+                          <a:latin typeface="Aptos"/>
+                        </a:defRPr>
+                      </a:pPr>
+                      <a:r>
+                        <a:t>10173/10,240</a:t>
+                      </a:r>
+                    </a:p>
+                  </a:txBody>
+                  <a:tcPr marL="109728" marT="109728">
+                    <a:solidFill>
+                      <a:srgbClr val="FFFFFF"/>
+                    </a:solidFill>
+                  </a:tcPr>
+                </a:tc>
+                <a:tc>
+                  <a:txBody>
+                    <a:bodyPr/>
+                    <a:lstStyle/>
+                    <a:p>
+                      <a:pPr>
+                        <a:defRPr sz="1600" b="0">
+                          <a:solidFill>
+                            <a:srgbClr val="17243A"/>
+                          </a:solidFill>
+                          <a:latin typeface="Aptos"/>
+                        </a:defRPr>
+                      </a:pPr>
+                      <a:r>
+                        <a:t>-48.23%</a:t>
+                      </a:r>
+                    </a:p>
+                  </a:txBody>
+                  <a:tcPr marL="109728" marT="109728">
+                    <a:solidFill>
+                      <a:srgbClr val="FFFFFF"/>
+                    </a:solidFill>
+                  </a:tcPr>
+                </a:tc>
+              </a:tr>
+              <a:tr h="463731">
+                <a:tc>
+                  <a:txBody>
+                    <a:bodyPr/>
+                    <a:lstStyle/>
+                    <a:p>
+                      <a:pPr>
+                        <a:defRPr sz="1600" b="0">
+                          <a:solidFill>
+                            <a:srgbClr val="17243A"/>
+                          </a:solidFill>
+                          <a:latin typeface="Aptos"/>
+                        </a:defRPr>
+                      </a:pPr>
+                      <a:r>
+                        <a:t>Official camera on trained geometry</a:t>
+                      </a:r>
+                    </a:p>
+                  </a:txBody>
+                  <a:tcPr marL="109728" marT="109728">
+                    <a:solidFill>
+                      <a:srgbClr val="E8EEF4"/>
+                    </a:solidFill>
+                  </a:tcPr>
+                </a:tc>
+                <a:tc>
+                  <a:txBody>
+                    <a:bodyPr/>
+                    <a:lstStyle/>
+                    <a:p>
+                      <a:pPr>
+                        <a:defRPr sz="1600" b="0">
+                          <a:solidFill>
+                            <a:srgbClr val="17243A"/>
+                          </a:solidFill>
+                          <a:latin typeface="Aptos"/>
+                        </a:defRPr>
+                      </a:pPr>
+                      <a:r>
+                        <a:t>4204/10,240</a:t>
+                      </a:r>
+                    </a:p>
+                  </a:txBody>
+                  <a:tcPr marL="109728" marT="109728">
+                    <a:solidFill>
+                      <a:srgbClr val="E8EEF4"/>
+                    </a:solidFill>
+                  </a:tcPr>
+                </a:tc>
+                <a:tc>
+                  <a:txBody>
+                    <a:bodyPr/>
+                    <a:lstStyle/>
+                    <a:p>
+                      <a:pPr>
+                        <a:defRPr sz="1600" b="0">
+                          <a:solidFill>
+                            <a:srgbClr val="17243A"/>
+                          </a:solidFill>
+                          <a:latin typeface="Aptos"/>
+                        </a:defRPr>
+                      </a:pPr>
+                      <a:r>
+                        <a:t>+5.65%</a:t>
+                      </a:r>
+                    </a:p>
+                  </a:txBody>
+                  <a:tcPr marL="109728" marT="109728">
+                    <a:solidFill>
+                      <a:srgbClr val="E8EEF4"/>
+                    </a:solidFill>
+                  </a:tcPr>
+                </a:tc>
+              </a:tr>
+              <a:tr h="463731">
+                <a:tc>
+                  <a:txBody>
+                    <a:bodyPr/>
+                    <a:lstStyle/>
+                    <a:p>
+                      <a:pPr>
+                        <a:defRPr sz="1600" b="0">
+                          <a:solidFill>
+                            <a:srgbClr val="17243A"/>
+                          </a:solidFill>
+                          <a:latin typeface="Aptos"/>
+                        </a:defRPr>
+                      </a:pPr>
+                      <a:r>
+                        <a:t>GT orientation: MPJPE</a:t>
+                      </a:r>
+                    </a:p>
+                  </a:txBody>
+                  <a:tcPr marL="109728" marT="109728">
+                    <a:solidFill>
+                      <a:srgbClr val="FFFFFF"/>
+                    </a:solidFill>
+                  </a:tcPr>
+                </a:tc>
+                <a:tc>
+                  <a:txBody>
+                    <a:bodyPr/>
+                    <a:lstStyle/>
+                    <a:p>
+                      <a:pPr>
+                        <a:defRPr sz="1600" b="0">
+                          <a:solidFill>
+                            <a:srgbClr val="17243A"/>
+                          </a:solidFill>
+                          <a:latin typeface="Aptos"/>
+                        </a:defRPr>
+                      </a:pPr>
+                      <a:r>
+                        <a:t>6640/10,240</a:t>
+                      </a:r>
+                    </a:p>
+                  </a:txBody>
+                  <a:tcPr marL="109728" marT="109728">
+                    <a:solidFill>
+                      <a:srgbClr val="FFFFFF"/>
+                    </a:solidFill>
+                  </a:tcPr>
+                </a:tc>
+                <a:tc>
+                  <a:txBody>
+                    <a:bodyPr/>
+                    <a:lstStyle/>
+                    <a:p>
+                      <a:pPr>
+                        <a:defRPr sz="1600" b="0">
+                          <a:solidFill>
+                            <a:srgbClr val="17243A"/>
+                          </a:solidFill>
+                          <a:latin typeface="Aptos"/>
+                        </a:defRPr>
+                      </a:pPr>
+                      <a:r>
+                        <a:t>-6.63%</a:t>
+                      </a:r>
+                    </a:p>
+                  </a:txBody>
+                  <a:tcPr marL="109728" marT="109728">
+                    <a:solidFill>
+                      <a:srgbClr val="FFFFFF"/>
+                    </a:solidFill>
+                  </a:tcPr>
+                </a:tc>
+              </a:tr>
+              <a:tr h="463731">
+                <a:tc>
+                  <a:txBody>
+                    <a:bodyPr/>
+                    <a:lstStyle/>
+                    <a:p>
+                      <a:pPr>
+                        <a:defRPr sz="1600" b="0">
+                          <a:solidFill>
+                            <a:srgbClr val="17243A"/>
+                          </a:solidFill>
+                          <a:latin typeface="Aptos"/>
+                        </a:defRPr>
+                      </a:pPr>
+                      <a:r>
+                        <a:t>GT fingers: PA-MPJPE</a:t>
+                      </a:r>
+                    </a:p>
+                  </a:txBody>
+                  <a:tcPr marL="109728" marT="109728">
+                    <a:solidFill>
+                      <a:srgbClr val="E8EEF4"/>
+                    </a:solidFill>
+                  </a:tcPr>
+                </a:tc>
+                <a:tc>
+                  <a:txBody>
+                    <a:bodyPr/>
+                    <a:lstStyle/>
+                    <a:p>
+                      <a:pPr>
+                        <a:defRPr sz="1600" b="0">
+                          <a:solidFill>
+                            <a:srgbClr val="17243A"/>
+                          </a:solidFill>
+                          <a:latin typeface="Aptos"/>
+                        </a:defRPr>
+                      </a:pPr>
+                      <a:r>
+                        <a:t>10145/10,240</a:t>
+                      </a:r>
+                    </a:p>
+                  </a:txBody>
+                  <a:tcPr marL="109728" marT="109728">
+                    <a:solidFill>
+                      <a:srgbClr val="E8EEF4"/>
+                    </a:solidFill>
+                  </a:tcPr>
+                </a:tc>
+                <a:tc>
+                  <a:txBody>
+                    <a:bodyPr/>
+                    <a:lstStyle/>
+                    <a:p>
+                      <a:pPr>
+                        <a:defRPr sz="1600" b="0">
+                          <a:solidFill>
+                            <a:srgbClr val="17243A"/>
+                          </a:solidFill>
+                          <a:latin typeface="Aptos"/>
+                        </a:defRPr>
+                      </a:pPr>
+                      <a:r>
+                        <a:t>-46.75%</a:t>
+                      </a:r>
+                    </a:p>
+                  </a:txBody>
+                  <a:tcPr marL="109728" marT="109728">
+                    <a:solidFill>
+                      <a:srgbClr val="E8EEF4"/>
+                    </a:solidFill>
+                  </a:tcPr>
+                </a:tc>
+              </a:tr>
+              <a:tr h="463731">
+                <a:tc>
+                  <a:txBody>
+                    <a:bodyPr/>
+                    <a:lstStyle/>
+                    <a:p>
+                      <a:pPr>
+                        <a:defRPr sz="1600" b="0">
+                          <a:solidFill>
+                            <a:srgbClr val="17243A"/>
+                          </a:solidFill>
+                          <a:latin typeface="Aptos"/>
+                        </a:defRPr>
+                      </a:pPr>
+                      <a:r>
+                        <a:t>GT full pose: MPJPE</a:t>
+                      </a:r>
+                    </a:p>
+                  </a:txBody>
+                  <a:tcPr marL="109728" marT="109728">
+                    <a:solidFill>
+                      <a:srgbClr val="FFFFFF"/>
+                    </a:solidFill>
+                  </a:tcPr>
+                </a:tc>
+                <a:tc>
+                  <a:txBody>
+                    <a:bodyPr/>
+                    <a:lstStyle/>
+                    <a:p>
+                      <a:pPr>
+                        <a:defRPr sz="1600" b="0">
+                          <a:solidFill>
+                            <a:srgbClr val="17243A"/>
+                          </a:solidFill>
+                          <a:latin typeface="Aptos"/>
+                        </a:defRPr>
+                      </a:pPr>
+                      <a:r>
+                        <a:t>10190/10,240</a:t>
+                      </a:r>
+                    </a:p>
+                  </a:txBody>
+                  <a:tcPr marL="109728" marT="109728">
+                    <a:solidFill>
+                      <a:srgbClr val="FFFFFF"/>
+                    </a:solidFill>
+                  </a:tcPr>
+                </a:tc>
+                <a:tc>
+                  <a:txBody>
+                    <a:bodyPr/>
+                    <a:lstStyle/>
+                    <a:p>
+                      <a:pPr>
+                        <a:defRPr sz="1600" b="0">
+                          <a:solidFill>
+                            <a:srgbClr val="17243A"/>
+                          </a:solidFill>
+                          <a:latin typeface="Aptos"/>
+                        </a:defRPr>
+                      </a:pPr>
+                      <a:r>
+                        <a:t>-52.57%</a:t>
+                      </a:r>
+                    </a:p>
+                  </a:txBody>
+                  <a:tcPr marL="109728" marT="109728">
+                    <a:solidFill>
+                      <a:srgbClr val="FFFFFF"/>
+                    </a:solidFill>
+                  </a:tcPr>
+                </a:tc>
+              </a:tr>
+              <a:tr h="463734">
+                <a:tc>
+                  <a:txBody>
+                    <a:bodyPr/>
+                    <a:lstStyle/>
+                    <a:p>
+                      <a:pPr>
+                        <a:defRPr sz="1600" b="0">
+                          <a:solidFill>
+                            <a:srgbClr val="17243A"/>
+                          </a:solidFill>
+                          <a:latin typeface="Aptos"/>
+                        </a:defRPr>
+                      </a:pPr>
+                      <a:r>
+                        <a:t>GT full pose: PVE</a:t>
+                      </a:r>
+                    </a:p>
+                  </a:txBody>
+                  <a:tcPr marL="109728" marT="109728">
+                    <a:solidFill>
+                      <a:srgbClr val="E8EEF4"/>
+                    </a:solidFill>
+                  </a:tcPr>
+                </a:tc>
+                <a:tc>
+                  <a:txBody>
+                    <a:bodyPr/>
+                    <a:lstStyle/>
+                    <a:p>
+                      <a:pPr>
+                        <a:defRPr sz="1600" b="0">
+                          <a:solidFill>
+                            <a:srgbClr val="17243A"/>
+                          </a:solidFill>
+                          <a:latin typeface="Aptos"/>
+                        </a:defRPr>
+                      </a:pPr>
+                      <a:r>
+                        <a:t>10214/10,240</a:t>
+                      </a:r>
+                    </a:p>
+                  </a:txBody>
+                  <a:tcPr marL="109728" marT="109728">
+                    <a:solidFill>
+                      <a:srgbClr val="E8EEF4"/>
+                    </a:solidFill>
+                  </a:tcPr>
+                </a:tc>
+                <a:tc>
+                  <a:txBody>
+                    <a:bodyPr/>
+                    <a:lstStyle/>
+                    <a:p>
+                      <a:pPr>
+                        <a:defRPr sz="1600" b="0">
+                          <a:solidFill>
+                            <a:srgbClr val="17243A"/>
+                          </a:solidFill>
+                          <a:latin typeface="Aptos"/>
+                        </a:defRPr>
+                      </a:pPr>
+                      <a:r>
+                        <a:t>-68.65%</a:t>
+                      </a:r>
+                    </a:p>
+                  </a:txBody>
+                  <a:tcPr marL="109728" marT="109728">
+                    <a:solidFill>
+                      <a:srgbClr val="E8EEF4"/>
+                    </a:solidFill>
+                  </a:tcPr>
+                </a:tc>
+              </a:tr>
+            </a:tbl>
+          </a:graphicData>
+        </a:graphic>
+      </p:graphicFrame>
+      <p:sp>
+        <p:nvSpPr>
+          <p:cNvPr id="7" name="TextBox 6"/>
+          <p:cNvSpPr txBox="1"/>
+          <p:nvPr/>
+        </p:nvSpPr>
+        <p:spPr>
+          <a:xfrm>
+            <a:off x="594360" y="5303520"/>
+            <a:ext cx="10972800" cy="822960"/>
+          </a:xfrm>
+          <a:prstGeom prst="rect">
+            <a:avLst/>
+          </a:prstGeom>
+          <a:noFill/>
+        </p:spPr>
+        <p:txBody>
+          <a:bodyPr wrap="square">
+            <a:spAutoFit/>
+          </a:bodyPr>
+          <a:lstStyle/>
+          <a:p>
+            <a:pPr>
+              <a:spcAft>
+                <a:spcPts val="1200"/>
+              </a:spcAft>
+              <a:defRPr sz="1900" b="0">
+                <a:solidFill>
+                  <a:srgbClr val="007F86"/>
+                </a:solidFill>
+                <a:latin typeface="Aptos"/>
+              </a:defRPr>
+            </a:pPr>
+            <a:r>
+              <a:t>Camera swap worsens reprojection by 5.65% median: geometry and camera are co-adapted.</a:t>
+            </a:r>
+          </a:p>
+          <a:p>
+            <a:pPr>
+              <a:spcAft>
+                <a:spcPts val="1200"/>
+              </a:spcAft>
+              <a:defRPr sz="1900" b="0">
+                <a:solidFill>
+                  <a:srgbClr val="007F86"/>
+                </a:solidFill>
+                <a:latin typeface="Aptos"/>
+              </a:defRPr>
+            </a:pPr>
+            <a:r>
+              <a:t>GT fingers cut PA-MPJPE by 46.75%; complete GT pose cuts MPJPE 52.57% and PVE 68.65%.</a:t>
+            </a:r>
+          </a:p>
+        </p:txBody>
+      </p:sp>
+    </p:spTree>
+  </p:cSld>
+  <p:clrMapOvr>
+    <a:masterClrMapping/>
+  </p:clrMapOvr>
+</p:sld>
+</file>
+
+<file path=ppt/slides/slide14.xml><?xml version="1.0" encoding="utf-8"?>
+<p:sld xmlns:a="http://schemas.openxmlformats.org/drawingml/2006/main" xmlns:p="http://schemas.openxmlformats.org/presentationml/2006/main" xmlns:r="http://schemas.openxmlformats.org/officeDocument/2006/relationships">
+  <p:cSld>
+    <p:bg>
+      <p:bgPr>
+        <a:solidFill>
+          <a:srgbClr val="F4F6FA"/>
+        </a:solidFill>
+        <a:effectLst/>
+      </p:bgPr>
+    </p:bg>
+    <p:spTree>
+      <p:nvGrpSpPr>
+        <p:cNvPr id="1" name=""/>
+        <p:cNvGrpSpPr/>
+        <p:nvPr/>
+      </p:nvGrpSpPr>
+      <p:grpSpPr/>
+      <p:sp>
+        <p:nvSpPr>
+          <p:cNvPr id="2" name="TextBox 1"/>
+          <p:cNvSpPr txBox="1"/>
+          <p:nvPr/>
+        </p:nvSpPr>
+        <p:spPr>
+          <a:xfrm>
+            <a:off x="457200" y="201168"/>
+            <a:ext cx="11247120" cy="548640"/>
+          </a:xfrm>
+          <a:prstGeom prst="rect">
+            <a:avLst/>
+          </a:prstGeom>
+          <a:noFill/>
+        </p:spPr>
+        <p:txBody>
+          <a:bodyPr wrap="square">
+            <a:spAutoFit/>
+          </a:bodyPr>
+          <a:lstStyle/>
+          <a:p>
+            <a:pPr>
+              <a:spcAft>
+                <a:spcPts val="1200"/>
+              </a:spcAft>
+              <a:defRPr sz="2800" b="1">
+                <a:solidFill>
+                  <a:srgbClr val="17243A"/>
+                </a:solidFill>
+                <a:latin typeface="Aptos"/>
+              </a:defRPr>
+            </a:pPr>
+            <a:r>
+              <a:t>Loss audit: explicit pose supervision is weak</a:t>
+            </a:r>
+          </a:p>
+        </p:txBody>
+      </p:sp>
+      <p:sp>
+        <p:nvSpPr>
+          <p:cNvPr id="3" name="TextBox 2"/>
+          <p:cNvSpPr txBox="1"/>
+          <p:nvPr/>
+        </p:nvSpPr>
+        <p:spPr>
+          <a:xfrm>
+            <a:off x="457200" y="868680"/>
+            <a:ext cx="11247120" cy="502920"/>
+          </a:xfrm>
+          <a:prstGeom prst="rect">
+            <a:avLst/>
+          </a:prstGeom>
+          <a:noFill/>
+        </p:spPr>
+        <p:txBody>
+          <a:bodyPr wrap="square">
+            <a:spAutoFit/>
+          </a:bodyPr>
+          <a:lstStyle/>
+          <a:p>
+            <a:pPr>
+              <a:spcAft>
+                <a:spcPts val="1200"/>
+              </a:spcAft>
+              <a:defRPr sz="1500" b="0">
+                <a:solidFill>
+                  <a:srgbClr val="58677B"/>
+                </a:solidFill>
+                <a:latin typeface="Aptos"/>
+              </a:defRPr>
+            </a:pPr>
+            <a:r>
+              <a:t>64 fixed samples, 8 local batches of 8; FP32 diagnostic gradients, no optimizer update.</a:t>
+            </a:r>
+          </a:p>
+        </p:txBody>
+      </p:sp>
+      <p:sp>
+        <p:nvSpPr>
+          <p:cNvPr id="4" name="TextBox 3"/>
+          <p:cNvSpPr txBox="1"/>
+          <p:nvPr/>
+        </p:nvSpPr>
+        <p:spPr>
+          <a:xfrm>
+            <a:off x="457200" y="6473952"/>
+            <a:ext cx="10881360" cy="228600"/>
+          </a:xfrm>
+          <a:prstGeom prst="rect">
+            <a:avLst/>
+          </a:prstGeom>
+          <a:noFill/>
+        </p:spPr>
+        <p:txBody>
+          <a:bodyPr wrap="square">
+            <a:spAutoFit/>
+          </a:bodyPr>
+          <a:lstStyle/>
+          <a:p>
+            <a:pPr>
+              <a:spcAft>
+                <a:spcPts val="1200"/>
+              </a:spcAft>
+              <a:defRPr sz="900" b="0">
+                <a:solidFill>
+                  <a:srgbClr val="58677B"/>
+                </a:solidFill>
+                <a:latin typeface="Aptos"/>
+              </a:defRPr>
+            </a:pPr>
+            <a:r>
+              <a:t>Sources: evaluation/freihand_loss_gradient_audit/{summary.csv,report.md,provenance.json}</a:t>
+            </a:r>
+          </a:p>
+        </p:txBody>
+      </p:sp>
+      <p:sp>
+        <p:nvSpPr>
+          <p:cNvPr id="5" name="TextBox 4"/>
+          <p:cNvSpPr txBox="1"/>
+          <p:nvPr/>
+        </p:nvSpPr>
+        <p:spPr>
+          <a:xfrm>
+            <a:off x="11292840" y="6437376"/>
+            <a:ext cx="457200" cy="274320"/>
+          </a:xfrm>
+          <a:prstGeom prst="rect">
+            <a:avLst/>
+          </a:prstGeom>
+          <a:noFill/>
+        </p:spPr>
+        <p:txBody>
+          <a:bodyPr wrap="square">
+            <a:spAutoFit/>
+          </a:bodyPr>
+          <a:lstStyle/>
+          <a:p>
+            <a:pPr>
+              <a:spcAft>
+                <a:spcPts val="1200"/>
+              </a:spcAft>
+              <a:defRPr sz="1100" b="0">
+                <a:solidFill>
+                  <a:srgbClr val="58677B"/>
+                </a:solidFill>
+                <a:latin typeface="Aptos"/>
+              </a:defRPr>
+            </a:pPr>
+            <a:r>
+              <a:t>14</a:t>
+            </a:r>
+          </a:p>
+        </p:txBody>
+      </p:sp>
+      <p:graphicFrame>
+        <p:nvGraphicFramePr>
+          <p:cNvPr id="6" name="Table 5"/>
+          <p:cNvGraphicFramePr>
+            <a:graphicFrameLocks noGrp="1"/>
+          </p:cNvGraphicFramePr>
+          <p:nvPr/>
+        </p:nvGraphicFramePr>
+        <p:xfrm>
+          <a:off x="502920" y="1645920"/>
+          <a:ext cx="11155680" cy="3246120"/>
+        </p:xfrm>
+        <a:graphic>
+          <a:graphicData uri="http://schemas.openxmlformats.org/drawingml/2006/table">
+            <a:tbl>
+              <a:tblPr firstRow="1" bandRow="1">
+                <a:tableStyleId>{5C22544A-7EE6-4342-B048-85BDC9FD1C3A}</a:tableStyleId>
+              </a:tblPr>
+              <a:tblGrid>
+                <a:gridCol w="1593668"/>
+                <a:gridCol w="1593668"/>
+                <a:gridCol w="1593668"/>
+                <a:gridCol w="1593668"/>
+                <a:gridCol w="1593668"/>
+                <a:gridCol w="1593668"/>
+                <a:gridCol w="1593672"/>
+              </a:tblGrid>
+              <a:tr h="463731">
+                <a:tc>
+                  <a:txBody>
+                    <a:bodyPr/>
+                    <a:lstStyle/>
+                    <a:p>
+                      <a:pPr>
+                        <a:defRPr sz="1600" b="1">
+                          <a:solidFill>
+                            <a:srgbClr val="FFFFFF"/>
+                          </a:solidFill>
+                          <a:latin typeface="Aptos"/>
+                        </a:defRPr>
+                      </a:pPr>
+                      <a:r>
+                        <a:t>Loss</a:t>
+                      </a:r>
+                    </a:p>
+                  </a:txBody>
+                  <a:tcPr marL="109728" marT="109728">
+                    <a:solidFill>
+                      <a:srgbClr val="17243A"/>
+                    </a:solidFill>
+                  </a:tcPr>
+                </a:tc>
+                <a:tc>
+                  <a:txBody>
+                    <a:bodyPr/>
+                    <a:lstStyle/>
+                    <a:p>
+                      <a:pPr>
+                        <a:defRPr sz="1600" b="1">
+                          <a:solidFill>
+                            <a:srgbClr val="FFFFFF"/>
+                          </a:solidFill>
+                          <a:latin typeface="Aptos"/>
+                        </a:defRPr>
+                      </a:pPr>
+                      <a:r>
+                        <a:t>Weight</a:t>
+                      </a:r>
+                    </a:p>
+                  </a:txBody>
+                  <a:tcPr marL="109728" marT="109728">
+                    <a:solidFill>
+                      <a:srgbClr val="17243A"/>
+                    </a:solidFill>
+                  </a:tcPr>
+                </a:tc>
+                <a:tc>
+                  <a:txBody>
+                    <a:bodyPr/>
+                    <a:lstStyle/>
+                    <a:p>
+                      <a:pPr>
+                        <a:defRPr sz="1600" b="1">
+                          <a:solidFill>
+                            <a:srgbClr val="FFFFFF"/>
+                          </a:solidFill>
+                          <a:latin typeface="Aptos"/>
+                        </a:defRPr>
+                      </a:pPr>
+                      <a:r>
+                        <a:t>Loss share</a:t>
+                      </a:r>
+                    </a:p>
+                  </a:txBody>
+                  <a:tcPr marL="109728" marT="109728">
+                    <a:solidFill>
+                      <a:srgbClr val="17243A"/>
+                    </a:solidFill>
+                  </a:tcPr>
+                </a:tc>
+                <a:tc>
+                  <a:txBody>
+                    <a:bodyPr/>
+                    <a:lstStyle/>
+                    <a:p>
+                      <a:pPr>
+                        <a:defRPr sz="1600" b="1">
+                          <a:solidFill>
+                            <a:srgbClr val="FFFFFF"/>
+                          </a:solidFill>
+                          <a:latin typeface="Aptos"/>
+                        </a:defRPr>
+                      </a:pPr>
+                      <a:r>
+                        <a:t>All grad</a:t>
+                      </a:r>
+                    </a:p>
+                  </a:txBody>
+                  <a:tcPr marL="109728" marT="109728">
+                    <a:solidFill>
+                      <a:srgbClr val="17243A"/>
+                    </a:solidFill>
+                  </a:tcPr>
+                </a:tc>
+                <a:tc>
+                  <a:txBody>
+                    <a:bodyPr/>
+                    <a:lstStyle/>
+                    <a:p>
+                      <a:pPr>
+                        <a:defRPr sz="1600" b="1">
+                          <a:solidFill>
+                            <a:srgbClr val="FFFFFF"/>
+                          </a:solidFill>
+                          <a:latin typeface="Aptos"/>
+                        </a:defRPr>
+                      </a:pPr>
+                      <a:r>
+                        <a:t>Pose head</a:t>
+                      </a:r>
+                    </a:p>
+                  </a:txBody>
+                  <a:tcPr marL="109728" marT="109728">
+                    <a:solidFill>
+                      <a:srgbClr val="17243A"/>
+                    </a:solidFill>
+                  </a:tcPr>
+                </a:tc>
+                <a:tc>
+                  <a:txBody>
+                    <a:bodyPr/>
+                    <a:lstStyle/>
+                    <a:p>
+                      <a:pPr>
+                        <a:defRPr sz="1600" b="1">
+                          <a:solidFill>
+                            <a:srgbClr val="FFFFFF"/>
+                          </a:solidFill>
+                          <a:latin typeface="Aptos"/>
+                        </a:defRPr>
+                      </a:pPr>
+                      <a:r>
+                        <a:t>Shape head</a:t>
+                      </a:r>
+                    </a:p>
+                  </a:txBody>
+                  <a:tcPr marL="109728" marT="109728">
+                    <a:solidFill>
+                      <a:srgbClr val="17243A"/>
+                    </a:solidFill>
+                  </a:tcPr>
+                </a:tc>
+                <a:tc>
+                  <a:txBody>
+                    <a:bodyPr/>
+                    <a:lstStyle/>
+                    <a:p>
+                      <a:pPr>
+                        <a:defRPr sz="1600" b="1">
+                          <a:solidFill>
+                            <a:srgbClr val="FFFFFF"/>
+                          </a:solidFill>
+                          <a:latin typeface="Aptos"/>
+                        </a:defRPr>
+                      </a:pPr>
+                      <a:r>
+                        <a:t>Camera head</a:t>
+                      </a:r>
+                    </a:p>
+                  </a:txBody>
+                  <a:tcPr marL="109728" marT="109728">
+                    <a:solidFill>
+                      <a:srgbClr val="17243A"/>
+                    </a:solidFill>
+                  </a:tcPr>
+                </a:tc>
+              </a:tr>
+              <a:tr h="463731">
+                <a:tc>
+                  <a:txBody>
+                    <a:bodyPr/>
+                    <a:lstStyle/>
+                    <a:p>
+                      <a:pPr>
+                        <a:defRPr sz="1600" b="0">
+                          <a:solidFill>
+                            <a:srgbClr val="17243A"/>
+                          </a:solidFill>
+                          <a:latin typeface="Aptos"/>
+                        </a:defRPr>
+                      </a:pPr>
+                      <a:r>
+                        <a:t>2D keypoints</a:t>
+                      </a:r>
+                    </a:p>
+                  </a:txBody>
+                  <a:tcPr marL="109728" marT="109728">
+                    <a:solidFill>
+                      <a:srgbClr val="FFFFFF"/>
+                    </a:solidFill>
+                  </a:tcPr>
+                </a:tc>
+                <a:tc>
+                  <a:txBody>
+                    <a:bodyPr/>
+                    <a:lstStyle/>
+                    <a:p>
+                      <a:pPr>
+                        <a:defRPr sz="1600" b="0">
+                          <a:solidFill>
+                            <a:srgbClr val="17243A"/>
+                          </a:solidFill>
+                          <a:latin typeface="Aptos"/>
+                        </a:defRPr>
+                      </a:pPr>
+                      <a:r>
+                        <a:t>0.01</a:t>
+                      </a:r>
+                    </a:p>
+                  </a:txBody>
+                  <a:tcPr marL="109728" marT="109728">
+                    <a:solidFill>
+                      <a:srgbClr val="FFFFFF"/>
+                    </a:solidFill>
+                  </a:tcPr>
+                </a:tc>
+                <a:tc>
+                  <a:txBody>
+                    <a:bodyPr/>
+                    <a:lstStyle/>
+                    <a:p>
+                      <a:pPr>
+                        <a:defRPr sz="1600" b="0">
+                          <a:solidFill>
+                            <a:srgbClr val="17243A"/>
+                          </a:solidFill>
+                          <a:latin typeface="Aptos"/>
+                        </a:defRPr>
+                      </a:pPr>
+                      <a:r>
+                        <a:t>25.67%</a:t>
+                      </a:r>
+                    </a:p>
+                  </a:txBody>
+                  <a:tcPr marL="109728" marT="109728">
+                    <a:solidFill>
+                      <a:srgbClr val="FFFFFF"/>
+                    </a:solidFill>
+                  </a:tcPr>
+                </a:tc>
+                <a:tc>
+                  <a:txBody>
+                    <a:bodyPr/>
+                    <a:lstStyle/>
+                    <a:p>
+                      <a:pPr>
+                        <a:defRPr sz="1600" b="0">
+                          <a:solidFill>
+                            <a:srgbClr val="17243A"/>
+                          </a:solidFill>
+                          <a:latin typeface="Aptos"/>
+                        </a:defRPr>
+                      </a:pPr>
+                      <a:r>
+                        <a:t>9.7168</a:t>
+                      </a:r>
+                    </a:p>
+                  </a:txBody>
+                  <a:tcPr marL="109728" marT="109728">
+                    <a:solidFill>
+                      <a:srgbClr val="FFFFFF"/>
+                    </a:solidFill>
+                  </a:tcPr>
+                </a:tc>
+                <a:tc>
+                  <a:txBody>
+                    <a:bodyPr/>
+                    <a:lstStyle/>
+                    <a:p>
+                      <a:pPr>
+                        <a:defRPr sz="1600" b="0">
+                          <a:solidFill>
+                            <a:srgbClr val="17243A"/>
+                          </a:solidFill>
+                          <a:latin typeface="Aptos"/>
+                        </a:defRPr>
+                      </a:pPr>
+                      <a:r>
+                        <a:t>0.2747</a:t>
+                      </a:r>
+                    </a:p>
+                  </a:txBody>
+                  <a:tcPr marL="109728" marT="109728">
+                    <a:solidFill>
+                      <a:srgbClr val="FFFFFF"/>
+                    </a:solidFill>
+                  </a:tcPr>
+                </a:tc>
+                <a:tc>
+                  <a:txBody>
+                    <a:bodyPr/>
+                    <a:lstStyle/>
+                    <a:p>
+                      <a:pPr>
+                        <a:defRPr sz="1600" b="0">
+                          <a:solidFill>
+                            <a:srgbClr val="17243A"/>
+                          </a:solidFill>
+                          <a:latin typeface="Aptos"/>
+                        </a:defRPr>
+                      </a:pPr>
+                      <a:r>
+                        <a:t>0.0334</a:t>
+                      </a:r>
+                    </a:p>
+                  </a:txBody>
+                  <a:tcPr marL="109728" marT="109728">
+                    <a:solidFill>
+                      <a:srgbClr val="FFFFFF"/>
+                    </a:solidFill>
+                  </a:tcPr>
+                </a:tc>
+                <a:tc>
+                  <a:txBody>
+                    <a:bodyPr/>
+                    <a:lstStyle/>
+                    <a:p>
+                      <a:pPr>
+                        <a:defRPr sz="1600" b="0">
+                          <a:solidFill>
+                            <a:srgbClr val="17243A"/>
+                          </a:solidFill>
+                          <a:latin typeface="Aptos"/>
+                        </a:defRPr>
+                      </a:pPr>
+                      <a:r>
+                        <a:t>9.2479</a:t>
+                      </a:r>
+                    </a:p>
+                  </a:txBody>
+                  <a:tcPr marL="109728" marT="109728">
+                    <a:solidFill>
+                      <a:srgbClr val="FFFFFF"/>
+                    </a:solidFill>
+                  </a:tcPr>
+                </a:tc>
+              </a:tr>
+              <a:tr h="463731">
+                <a:tc>
+                  <a:txBody>
+                    <a:bodyPr/>
+                    <a:lstStyle/>
+                    <a:p>
+                      <a:pPr>
+                        <a:defRPr sz="1600" b="0">
+                          <a:solidFill>
+                            <a:srgbClr val="17243A"/>
+                          </a:solidFill>
+                          <a:latin typeface="Aptos"/>
+                        </a:defRPr>
+                      </a:pPr>
+                      <a:r>
+                        <a:t>3D keypoints</a:t>
+                      </a:r>
+                    </a:p>
+                  </a:txBody>
+                  <a:tcPr marL="109728" marT="109728">
+                    <a:solidFill>
+                      <a:srgbClr val="E8EEF4"/>
+                    </a:solidFill>
+                  </a:tcPr>
+                </a:tc>
+                <a:tc>
+                  <a:txBody>
+                    <a:bodyPr/>
+                    <a:lstStyle/>
+                    <a:p>
+                      <a:pPr>
+                        <a:defRPr sz="1600" b="0">
+                          <a:solidFill>
+                            <a:srgbClr val="17243A"/>
+                          </a:solidFill>
+                          <a:latin typeface="Aptos"/>
+                        </a:defRPr>
+                      </a:pPr>
+                      <a:r>
+                        <a:t>0.05</a:t>
+                      </a:r>
+                    </a:p>
+                  </a:txBody>
+                  <a:tcPr marL="109728" marT="109728">
+                    <a:solidFill>
+                      <a:srgbClr val="E8EEF4"/>
+                    </a:solidFill>
+                  </a:tcPr>
+                </a:tc>
+                <a:tc>
+                  <a:txBody>
+                    <a:bodyPr/>
+                    <a:lstStyle/>
+                    <a:p>
+                      <a:pPr>
+                        <a:defRPr sz="1600" b="0">
+                          <a:solidFill>
+                            <a:srgbClr val="17243A"/>
+                          </a:solidFill>
+                          <a:latin typeface="Aptos"/>
+                        </a:defRPr>
+                      </a:pPr>
+                      <a:r>
+                        <a:t>58.77%</a:t>
+                      </a:r>
+                    </a:p>
+                  </a:txBody>
+                  <a:tcPr marL="109728" marT="109728">
+                    <a:solidFill>
+                      <a:srgbClr val="E8EEF4"/>
+                    </a:solidFill>
+                  </a:tcPr>
+                </a:tc>
+                <a:tc>
+                  <a:txBody>
+                    <a:bodyPr/>
+                    <a:lstStyle/>
+                    <a:p>
+                      <a:pPr>
+                        <a:defRPr sz="1600" b="0">
+                          <a:solidFill>
+                            <a:srgbClr val="17243A"/>
+                          </a:solidFill>
+                          <a:latin typeface="Aptos"/>
+                        </a:defRPr>
+                      </a:pPr>
+                      <a:r>
+                        <a:t>2.1886</a:t>
+                      </a:r>
+                    </a:p>
+                  </a:txBody>
+                  <a:tcPr marL="109728" marT="109728">
+                    <a:solidFill>
+                      <a:srgbClr val="E8EEF4"/>
+                    </a:solidFill>
+                  </a:tcPr>
+                </a:tc>
+                <a:tc>
+                  <a:txBody>
+                    <a:bodyPr/>
+                    <a:lstStyle/>
+                    <a:p>
+                      <a:pPr>
+                        <a:defRPr sz="1600" b="0">
+                          <a:solidFill>
+                            <a:srgbClr val="17243A"/>
+                          </a:solidFill>
+                          <a:latin typeface="Aptos"/>
+                        </a:defRPr>
+                      </a:pPr>
+                      <a:r>
+                        <a:t>0.4636</a:t>
+                      </a:r>
+                    </a:p>
+                  </a:txBody>
+                  <a:tcPr marL="109728" marT="109728">
+                    <a:solidFill>
+                      <a:srgbClr val="E8EEF4"/>
+                    </a:solidFill>
+                  </a:tcPr>
+                </a:tc>
+                <a:tc>
+                  <a:txBody>
+                    <a:bodyPr/>
+                    <a:lstStyle/>
+                    <a:p>
+                      <a:pPr>
+                        <a:defRPr sz="1600" b="0">
+                          <a:solidFill>
+                            <a:srgbClr val="17243A"/>
+                          </a:solidFill>
+                          <a:latin typeface="Aptos"/>
+                        </a:defRPr>
+                      </a:pPr>
+                      <a:r>
+                        <a:t>0.0402</a:t>
+                      </a:r>
+                    </a:p>
+                  </a:txBody>
+                  <a:tcPr marL="109728" marT="109728">
+                    <a:solidFill>
+                      <a:srgbClr val="E8EEF4"/>
+                    </a:solidFill>
+                  </a:tcPr>
+                </a:tc>
+                <a:tc>
+                  <a:txBody>
+                    <a:bodyPr/>
+                    <a:lstStyle/>
+                    <a:p>
+                      <a:pPr>
+                        <a:defRPr sz="1600" b="0">
+                          <a:solidFill>
+                            <a:srgbClr val="17243A"/>
+                          </a:solidFill>
+                          <a:latin typeface="Aptos"/>
+                        </a:defRPr>
+                      </a:pPr>
+                      <a:r>
+                        <a:t>0.0000</a:t>
+                      </a:r>
+                    </a:p>
+                  </a:txBody>
+                  <a:tcPr marL="109728" marT="109728">
+                    <a:solidFill>
+                      <a:srgbClr val="E8EEF4"/>
+                    </a:solidFill>
+                  </a:tcPr>
+                </a:tc>
+              </a:tr>
+              <a:tr h="463731">
+                <a:tc>
+                  <a:txBody>
+                    <a:bodyPr/>
+                    <a:lstStyle/>
+                    <a:p>
+                      <a:pPr>
+                        <a:defRPr sz="1600" b="0">
+                          <a:solidFill>
+                            <a:srgbClr val="17243A"/>
+                          </a:solidFill>
+                          <a:latin typeface="Aptos"/>
+                        </a:defRPr>
+                      </a:pPr>
+                      <a:r>
+                        <a:t>Global orientation</a:t>
+                      </a:r>
+                    </a:p>
+                  </a:txBody>
+                  <a:tcPr marL="109728" marT="109728">
+                    <a:solidFill>
+                      <a:srgbClr val="FFFFFF"/>
+                    </a:solidFill>
+                  </a:tcPr>
+                </a:tc>
+                <a:tc>
+                  <a:txBody>
+                    <a:bodyPr/>
+                    <a:lstStyle/>
+                    <a:p>
+                      <a:pPr>
+                        <a:defRPr sz="1600" b="0">
+                          <a:solidFill>
+                            <a:srgbClr val="17243A"/>
+                          </a:solidFill>
+                          <a:latin typeface="Aptos"/>
+                        </a:defRPr>
+                      </a:pPr>
+                      <a:r>
+                        <a:t>0.001</a:t>
+                      </a:r>
+                    </a:p>
+                  </a:txBody>
+                  <a:tcPr marL="109728" marT="109728">
+                    <a:solidFill>
+                      <a:srgbClr val="FFFFFF"/>
+                    </a:solidFill>
+                  </a:tcPr>
+                </a:tc>
+                <a:tc>
+                  <a:txBody>
+                    <a:bodyPr/>
+                    <a:lstStyle/>
+                    <a:p>
+                      <a:pPr>
+                        <a:defRPr sz="1600" b="0">
+                          <a:solidFill>
+                            <a:srgbClr val="17243A"/>
+                          </a:solidFill>
+                          <a:latin typeface="Aptos"/>
+                        </a:defRPr>
+                      </a:pPr>
+                      <a:r>
+                        <a:t>0.16%</a:t>
+                      </a:r>
+                    </a:p>
+                  </a:txBody>
+                  <a:tcPr marL="109728" marT="109728">
+                    <a:solidFill>
+                      <a:srgbClr val="FFFFFF"/>
+                    </a:solidFill>
+                  </a:tcPr>
+                </a:tc>
+                <a:tc>
+                  <a:txBody>
+                    <a:bodyPr/>
+                    <a:lstStyle/>
+                    <a:p>
+                      <a:pPr>
+                        <a:defRPr sz="1600" b="0">
+                          <a:solidFill>
+                            <a:srgbClr val="17243A"/>
+                          </a:solidFill>
+                          <a:latin typeface="Aptos"/>
+                        </a:defRPr>
+                      </a:pPr>
+                      <a:r>
+                        <a:t>0.0164</a:t>
+                      </a:r>
+                    </a:p>
+                  </a:txBody>
+                  <a:tcPr marL="109728" marT="109728">
+                    <a:solidFill>
+                      <a:srgbClr val="FFFFFF"/>
+                    </a:solidFill>
+                  </a:tcPr>
+                </a:tc>
+                <a:tc>
+                  <a:txBody>
+                    <a:bodyPr/>
+                    <a:lstStyle/>
+                    <a:p>
+                      <a:pPr>
+                        <a:defRPr sz="1600" b="0">
+                          <a:solidFill>
+                            <a:srgbClr val="17243A"/>
+                          </a:solidFill>
+                          <a:latin typeface="Aptos"/>
+                        </a:defRPr>
+                      </a:pPr>
+                      <a:r>
+                        <a:t>0.0038</a:t>
+                      </a:r>
+                    </a:p>
+                  </a:txBody>
+                  <a:tcPr marL="109728" marT="109728">
+                    <a:solidFill>
+                      <a:srgbClr val="FFFFFF"/>
+                    </a:solidFill>
+                  </a:tcPr>
+                </a:tc>
+                <a:tc>
+                  <a:txBody>
+                    <a:bodyPr/>
+                    <a:lstStyle/>
+                    <a:p>
+                      <a:pPr>
+                        <a:defRPr sz="1600" b="0">
+                          <a:solidFill>
+                            <a:srgbClr val="17243A"/>
+                          </a:solidFill>
+                          <a:latin typeface="Aptos"/>
+                        </a:defRPr>
+                      </a:pPr>
+                      <a:r>
+                        <a:t>0.0000</a:t>
+                      </a:r>
+                    </a:p>
+                  </a:txBody>
+                  <a:tcPr marL="109728" marT="109728">
+                    <a:solidFill>
+                      <a:srgbClr val="FFFFFF"/>
+                    </a:solidFill>
+                  </a:tcPr>
+                </a:tc>
+                <a:tc>
+                  <a:txBody>
+                    <a:bodyPr/>
+                    <a:lstStyle/>
+                    <a:p>
+                      <a:pPr>
+                        <a:defRPr sz="1600" b="0">
+                          <a:solidFill>
+                            <a:srgbClr val="17243A"/>
+                          </a:solidFill>
+                          <a:latin typeface="Aptos"/>
+                        </a:defRPr>
+                      </a:pPr>
+                      <a:r>
+                        <a:t>0.0000</a:t>
+                      </a:r>
+                    </a:p>
+                  </a:txBody>
+                  <a:tcPr marL="109728" marT="109728">
+                    <a:solidFill>
+                      <a:srgbClr val="FFFFFF"/>
+                    </a:solidFill>
+                  </a:tcPr>
+                </a:tc>
+              </a:tr>
+              <a:tr h="463731">
+                <a:tc>
+                  <a:txBody>
+                    <a:bodyPr/>
+                    <a:lstStyle/>
+                    <a:p>
+                      <a:pPr>
+                        <a:defRPr sz="1600" b="0">
+                          <a:solidFill>
+                            <a:srgbClr val="17243A"/>
+                          </a:solidFill>
+                          <a:latin typeface="Aptos"/>
+                        </a:defRPr>
+                      </a:pPr>
+                      <a:r>
+                        <a:t>Finger pose</a:t>
+                      </a:r>
+                    </a:p>
+                  </a:txBody>
+                  <a:tcPr marL="109728" marT="109728">
+                    <a:solidFill>
+                      <a:srgbClr val="E8EEF4"/>
+                    </a:solidFill>
+                  </a:tcPr>
+                </a:tc>
+                <a:tc>
+                  <a:txBody>
+                    <a:bodyPr/>
+                    <a:lstStyle/>
+                    <a:p>
+                      <a:pPr>
+                        <a:defRPr sz="1600" b="0">
+                          <a:solidFill>
+                            <a:srgbClr val="17243A"/>
+                          </a:solidFill>
+                          <a:latin typeface="Aptos"/>
+                        </a:defRPr>
+                      </a:pPr>
+                      <a:r>
+                        <a:t>0.001</a:t>
+                      </a:r>
+                    </a:p>
+                  </a:txBody>
+                  <a:tcPr marL="109728" marT="109728">
+                    <a:solidFill>
+                      <a:srgbClr val="E8EEF4"/>
+                    </a:solidFill>
+                  </a:tcPr>
+                </a:tc>
+                <a:tc>
+                  <a:txBody>
+                    <a:bodyPr/>
+                    <a:lstStyle/>
+                    <a:p>
+                      <a:pPr>
+                        <a:defRPr sz="1600" b="0">
+                          <a:solidFill>
+                            <a:srgbClr val="17243A"/>
+                          </a:solidFill>
+                          <a:latin typeface="Aptos"/>
+                        </a:defRPr>
+                      </a:pPr>
+                      <a:r>
+                        <a:t>7.96%</a:t>
+                      </a:r>
+                    </a:p>
+                  </a:txBody>
+                  <a:tcPr marL="109728" marT="109728">
+                    <a:solidFill>
+                      <a:srgbClr val="E8EEF4"/>
+                    </a:solidFill>
+                  </a:tcPr>
+                </a:tc>
+                <a:tc>
+                  <a:txBody>
+                    <a:bodyPr/>
+                    <a:lstStyle/>
+                    <a:p>
+                      <a:pPr>
+                        <a:defRPr sz="1600" b="0">
+                          <a:solidFill>
+                            <a:srgbClr val="17243A"/>
+                          </a:solidFill>
+                          <a:latin typeface="Aptos"/>
+                        </a:defRPr>
+                      </a:pPr>
+                      <a:r>
+                        <a:t>0.2433</a:t>
+                      </a:r>
+                    </a:p>
+                  </a:txBody>
+                  <a:tcPr marL="109728" marT="109728">
+                    <a:solidFill>
+                      <a:srgbClr val="E8EEF4"/>
+                    </a:solidFill>
+                  </a:tcPr>
+                </a:tc>
+                <a:tc>
+                  <a:txBody>
+                    <a:bodyPr/>
+                    <a:lstStyle/>
+                    <a:p>
+                      <a:pPr>
+                        <a:defRPr sz="1600" b="0">
+                          <a:solidFill>
+                            <a:srgbClr val="17243A"/>
+                          </a:solidFill>
+                          <a:latin typeface="Aptos"/>
+                        </a:defRPr>
+                      </a:pPr>
+                      <a:r>
+                        <a:t>0.0592</a:t>
+                      </a:r>
+                    </a:p>
+                  </a:txBody>
+                  <a:tcPr marL="109728" marT="109728">
+                    <a:solidFill>
+                      <a:srgbClr val="E8EEF4"/>
+                    </a:solidFill>
+                  </a:tcPr>
+                </a:tc>
+                <a:tc>
+                  <a:txBody>
+                    <a:bodyPr/>
+                    <a:lstStyle/>
+                    <a:p>
+                      <a:pPr>
+                        <a:defRPr sz="1600" b="0">
+                          <a:solidFill>
+                            <a:srgbClr val="17243A"/>
+                          </a:solidFill>
+                          <a:latin typeface="Aptos"/>
+                        </a:defRPr>
+                      </a:pPr>
+                      <a:r>
+                        <a:t>0.0000</a:t>
+                      </a:r>
+                    </a:p>
+                  </a:txBody>
+                  <a:tcPr marL="109728" marT="109728">
+                    <a:solidFill>
+                      <a:srgbClr val="E8EEF4"/>
+                    </a:solidFill>
+                  </a:tcPr>
+                </a:tc>
+                <a:tc>
+                  <a:txBody>
+                    <a:bodyPr/>
+                    <a:lstStyle/>
+                    <a:p>
+                      <a:pPr>
+                        <a:defRPr sz="1600" b="0">
+                          <a:solidFill>
+                            <a:srgbClr val="17243A"/>
+                          </a:solidFill>
+                          <a:latin typeface="Aptos"/>
+                        </a:defRPr>
+                      </a:pPr>
+                      <a:r>
+                        <a:t>0.0000</a:t>
+                      </a:r>
+                    </a:p>
+                  </a:txBody>
+                  <a:tcPr marL="109728" marT="109728">
+                    <a:solidFill>
+                      <a:srgbClr val="E8EEF4"/>
+                    </a:solidFill>
+                  </a:tcPr>
+                </a:tc>
+              </a:tr>
+              <a:tr h="463731">
+                <a:tc>
+                  <a:txBody>
+                    <a:bodyPr/>
+                    <a:lstStyle/>
+                    <a:p>
+                      <a:pPr>
+                        <a:defRPr sz="1600" b="0">
+                          <a:solidFill>
+                            <a:srgbClr val="17243A"/>
+                          </a:solidFill>
+                          <a:latin typeface="Aptos"/>
+                        </a:defRPr>
+                      </a:pPr>
+                      <a:r>
+                        <a:t>Betas</a:t>
+                      </a:r>
+                    </a:p>
+                  </a:txBody>
+                  <a:tcPr marL="109728" marT="109728">
+                    <a:solidFill>
+                      <a:srgbClr val="FFFFFF"/>
+                    </a:solidFill>
+                  </a:tcPr>
+                </a:tc>
+                <a:tc>
+                  <a:txBody>
+                    <a:bodyPr/>
+                    <a:lstStyle/>
+                    <a:p>
+                      <a:pPr>
+                        <a:defRPr sz="1600" b="0">
+                          <a:solidFill>
+                            <a:srgbClr val="17243A"/>
+                          </a:solidFill>
+                          <a:latin typeface="Aptos"/>
+                        </a:defRPr>
+                      </a:pPr>
+                      <a:r>
+                        <a:t>0.0005</a:t>
+                      </a:r>
+                    </a:p>
+                  </a:txBody>
+                  <a:tcPr marL="109728" marT="109728">
+                    <a:solidFill>
+                      <a:srgbClr val="FFFFFF"/>
+                    </a:solidFill>
+                  </a:tcPr>
+                </a:tc>
+                <a:tc>
+                  <a:txBody>
+                    <a:bodyPr/>
+                    <a:lstStyle/>
+                    <a:p>
+                      <a:pPr>
+                        <a:defRPr sz="1600" b="0">
+                          <a:solidFill>
+                            <a:srgbClr val="17243A"/>
+                          </a:solidFill>
+                          <a:latin typeface="Aptos"/>
+                        </a:defRPr>
+                      </a:pPr>
+                      <a:r>
+                        <a:t>6.64%</a:t>
+                      </a:r>
+                    </a:p>
+                  </a:txBody>
+                  <a:tcPr marL="109728" marT="109728">
+                    <a:solidFill>
+                      <a:srgbClr val="FFFFFF"/>
+                    </a:solidFill>
+                  </a:tcPr>
+                </a:tc>
+                <a:tc>
+                  <a:txBody>
+                    <a:bodyPr/>
+                    <a:lstStyle/>
+                    <a:p>
+                      <a:pPr>
+                        <a:defRPr sz="1600" b="0">
+                          <a:solidFill>
+                            <a:srgbClr val="17243A"/>
+                          </a:solidFill>
+                          <a:latin typeface="Aptos"/>
+                        </a:defRPr>
+                      </a:pPr>
+                      <a:r>
+                        <a:t>0.2306</a:t>
+                      </a:r>
+                    </a:p>
+                  </a:txBody>
+                  <a:tcPr marL="109728" marT="109728">
+                    <a:solidFill>
+                      <a:srgbClr val="FFFFFF"/>
+                    </a:solidFill>
+                  </a:tcPr>
+                </a:tc>
+                <a:tc>
+                  <a:txBody>
+                    <a:bodyPr/>
+                    <a:lstStyle/>
+                    <a:p>
+                      <a:pPr>
+                        <a:defRPr sz="1600" b="0">
+                          <a:solidFill>
+                            <a:srgbClr val="17243A"/>
+                          </a:solidFill>
+                          <a:latin typeface="Aptos"/>
+                        </a:defRPr>
+                      </a:pPr>
+                      <a:r>
+                        <a:t>0.0000</a:t>
+                      </a:r>
+                    </a:p>
+                  </a:txBody>
+                  <a:tcPr marL="109728" marT="109728">
+                    <a:solidFill>
+                      <a:srgbClr val="FFFFFF"/>
+                    </a:solidFill>
+                  </a:tcPr>
+                </a:tc>
+                <a:tc>
+                  <a:txBody>
+                    <a:bodyPr/>
+                    <a:lstStyle/>
+                    <a:p>
+                      <a:pPr>
+                        <a:defRPr sz="1600" b="0">
+                          <a:solidFill>
+                            <a:srgbClr val="17243A"/>
+                          </a:solidFill>
+                          <a:latin typeface="Aptos"/>
+                        </a:defRPr>
+                      </a:pPr>
+                      <a:r>
+                        <a:t>0.0230</a:t>
+                      </a:r>
+                    </a:p>
+                  </a:txBody>
+                  <a:tcPr marL="109728" marT="109728">
+                    <a:solidFill>
+                      <a:srgbClr val="FFFFFF"/>
+                    </a:solidFill>
+                  </a:tcPr>
+                </a:tc>
+                <a:tc>
+                  <a:txBody>
+                    <a:bodyPr/>
+                    <a:lstStyle/>
+                    <a:p>
+                      <a:pPr>
+                        <a:defRPr sz="1600" b="0">
+                          <a:solidFill>
+                            <a:srgbClr val="17243A"/>
+                          </a:solidFill>
+                          <a:latin typeface="Aptos"/>
+                        </a:defRPr>
+                      </a:pPr>
+                      <a:r>
+                        <a:t>0.0000</a:t>
+                      </a:r>
+                    </a:p>
+                  </a:txBody>
+                  <a:tcPr marL="109728" marT="109728">
+                    <a:solidFill>
+                      <a:srgbClr val="FFFFFF"/>
+                    </a:solidFill>
+                  </a:tcPr>
+                </a:tc>
+              </a:tr>
+              <a:tr h="463734">
+                <a:tc>
+                  <a:txBody>
+                    <a:bodyPr/>
+                    <a:lstStyle/>
+                    <a:p>
+                      <a:pPr>
+                        <a:defRPr sz="1600" b="0">
+                          <a:solidFill>
+                            <a:srgbClr val="17243A"/>
+                          </a:solidFill>
+                          <a:latin typeface="Aptos"/>
+                        </a:defRPr>
+                      </a:pPr>
+                      <a:r>
+                        <a:t>Adversarial</a:t>
+                      </a:r>
+                    </a:p>
+                  </a:txBody>
+                  <a:tcPr marL="109728" marT="109728">
+                    <a:solidFill>
+                      <a:srgbClr val="E8EEF4"/>
+                    </a:solidFill>
+                  </a:tcPr>
+                </a:tc>
+                <a:tc>
+                  <a:txBody>
+                    <a:bodyPr/>
+                    <a:lstStyle/>
+                    <a:p>
+                      <a:pPr>
+                        <a:defRPr sz="1600" b="0">
+                          <a:solidFill>
+                            <a:srgbClr val="17243A"/>
+                          </a:solidFill>
+                          <a:latin typeface="Aptos"/>
+                        </a:defRPr>
+                      </a:pPr>
+                      <a:r>
+                        <a:t>0.0005</a:t>
+                      </a:r>
+                    </a:p>
+                  </a:txBody>
+                  <a:tcPr marL="109728" marT="109728">
+                    <a:solidFill>
+                      <a:srgbClr val="E8EEF4"/>
+                    </a:solidFill>
+                  </a:tcPr>
+                </a:tc>
+                <a:tc>
+                  <a:txBody>
+                    <a:bodyPr/>
+                    <a:lstStyle/>
+                    <a:p>
+                      <a:pPr>
+                        <a:defRPr sz="1600" b="0">
+                          <a:solidFill>
+                            <a:srgbClr val="17243A"/>
+                          </a:solidFill>
+                          <a:latin typeface="Aptos"/>
+                        </a:defRPr>
+                      </a:pPr>
+                      <a:r>
+                        <a:t>0.80%</a:t>
+                      </a:r>
+                    </a:p>
+                  </a:txBody>
+                  <a:tcPr marL="109728" marT="109728">
+                    <a:solidFill>
+                      <a:srgbClr val="E8EEF4"/>
+                    </a:solidFill>
+                  </a:tcPr>
+                </a:tc>
+                <a:tc>
+                  <a:txBody>
+                    <a:bodyPr/>
+                    <a:lstStyle/>
+                    <a:p>
+                      <a:pPr>
+                        <a:defRPr sz="1600" b="0">
+                          <a:solidFill>
+                            <a:srgbClr val="17243A"/>
+                          </a:solidFill>
+                          <a:latin typeface="Aptos"/>
+                        </a:defRPr>
+                      </a:pPr>
+                      <a:r>
+                        <a:t>0.0164</a:t>
+                      </a:r>
+                    </a:p>
+                  </a:txBody>
+                  <a:tcPr marL="109728" marT="109728">
+                    <a:solidFill>
+                      <a:srgbClr val="E8EEF4"/>
+                    </a:solidFill>
+                  </a:tcPr>
+                </a:tc>
+                <a:tc>
+                  <a:txBody>
+                    <a:bodyPr/>
+                    <a:lstStyle/>
+                    <a:p>
+                      <a:pPr>
+                        <a:defRPr sz="1600" b="0">
+                          <a:solidFill>
+                            <a:srgbClr val="17243A"/>
+                          </a:solidFill>
+                          <a:latin typeface="Aptos"/>
+                        </a:defRPr>
+                      </a:pPr>
+                      <a:r>
+                        <a:t>0.0072</a:t>
+                      </a:r>
+                    </a:p>
+                  </a:txBody>
+                  <a:tcPr marL="109728" marT="109728">
+                    <a:solidFill>
+                      <a:srgbClr val="E8EEF4"/>
+                    </a:solidFill>
+                  </a:tcPr>
+                </a:tc>
+                <a:tc>
+                  <a:txBody>
+                    <a:bodyPr/>
+                    <a:lstStyle/>
+                    <a:p>
+                      <a:pPr>
+                        <a:defRPr sz="1600" b="0">
+                          <a:solidFill>
+                            <a:srgbClr val="17243A"/>
+                          </a:solidFill>
+                          <a:latin typeface="Aptos"/>
+                        </a:defRPr>
+                      </a:pPr>
+                      <a:r>
+                        <a:t>0.0000</a:t>
+                      </a:r>
+                    </a:p>
+                  </a:txBody>
+                  <a:tcPr marL="109728" marT="109728">
+                    <a:solidFill>
+                      <a:srgbClr val="E8EEF4"/>
+                    </a:solidFill>
+                  </a:tcPr>
+                </a:tc>
+                <a:tc>
+                  <a:txBody>
+                    <a:bodyPr/>
+                    <a:lstStyle/>
+                    <a:p>
+                      <a:pPr>
+                        <a:defRPr sz="1600" b="0">
+                          <a:solidFill>
+                            <a:srgbClr val="17243A"/>
+                          </a:solidFill>
+                          <a:latin typeface="Aptos"/>
+                        </a:defRPr>
+                      </a:pPr>
+                      <a:r>
+                        <a:t>0.0000</a:t>
+                      </a:r>
+                    </a:p>
+                  </a:txBody>
+                  <a:tcPr marL="109728" marT="109728">
+                    <a:solidFill>
+                      <a:srgbClr val="E8EEF4"/>
+                    </a:solidFill>
+                  </a:tcPr>
+                </a:tc>
+              </a:tr>
+            </a:tbl>
+          </a:graphicData>
+        </a:graphic>
+      </p:graphicFrame>
+      <p:sp>
+        <p:nvSpPr>
+          <p:cNvPr id="7" name="TextBox 6"/>
+          <p:cNvSpPr txBox="1"/>
+          <p:nvPr/>
+        </p:nvSpPr>
+        <p:spPr>
+          <a:xfrm>
+            <a:off x="594360" y="5257800"/>
+            <a:ext cx="10972800" cy="914400"/>
+          </a:xfrm>
+          <a:prstGeom prst="rect">
+            <a:avLst/>
+          </a:prstGeom>
+          <a:noFill/>
+        </p:spPr>
+        <p:txBody>
+          <a:bodyPr wrap="square">
+            <a:spAutoFit/>
+          </a:bodyPr>
+          <a:lstStyle/>
+          <a:p>
+            <a:pPr>
+              <a:spcAft>
+                <a:spcPts val="1200"/>
+              </a:spcAft>
+              <a:defRPr sz="1800" b="0">
+                <a:solidFill>
+                  <a:srgbClr val="007F86"/>
+                </a:solidFill>
+                <a:latin typeface="Aptos"/>
+              </a:defRPr>
+            </a:pPr>
+            <a:r>
+              <a:t>2D + 3D keypoints supply 84.44% of the weighted objective. Global-orientation supervision is only 0.16%.</a:t>
+            </a:r>
+          </a:p>
+          <a:p>
+            <a:pPr>
+              <a:spcAft>
+                <a:spcPts val="1200"/>
+              </a:spcAft>
+              <a:defRPr sz="1800" b="0">
+                <a:solidFill>
+                  <a:srgbClr val="007F86"/>
+                </a:solidFill>
+                <a:latin typeface="Aptos"/>
+              </a:defRPr>
+            </a:pPr>
+            <a:r>
+              <a:t>Betas are active (6.64%; grad 0.231), so increasing beta weight is not the evidence-based first repair.</a:t>
+            </a:r>
+          </a:p>
+        </p:txBody>
+      </p:sp>
+    </p:spTree>
+  </p:cSld>
+  <p:clrMapOvr>
+    <a:masterClrMapping/>
+  </p:clrMapOvr>
+</p:sld>
+</file>
+
+<file path=ppt/slides/slide15.xml><?xml version="1.0" encoding="utf-8"?>
+<p:sld xmlns:a="http://schemas.openxmlformats.org/drawingml/2006/main" xmlns:p="http://schemas.openxmlformats.org/presentationml/2006/main" xmlns:r="http://schemas.openxmlformats.org/officeDocument/2006/relationships">
+  <p:cSld>
+    <p:bg>
+      <p:bgPr>
+        <a:solidFill>
+          <a:srgbClr val="F4F6FA"/>
+        </a:solidFill>
+        <a:effectLst/>
+      </p:bgPr>
+    </p:bg>
+    <p:spTree>
+      <p:nvGrpSpPr>
+        <p:cNvPr id="1" name=""/>
+        <p:cNvGrpSpPr/>
+        <p:nvPr/>
+      </p:nvGrpSpPr>
+      <p:grpSpPr/>
+      <p:sp>
+        <p:nvSpPr>
+          <p:cNvPr id="2" name="TextBox 1"/>
+          <p:cNvSpPr txBox="1"/>
+          <p:nvPr/>
+        </p:nvSpPr>
+        <p:spPr>
+          <a:xfrm>
+            <a:off x="457200" y="201168"/>
+            <a:ext cx="11247120" cy="548640"/>
+          </a:xfrm>
+          <a:prstGeom prst="rect">
+            <a:avLst/>
+          </a:prstGeom>
+          <a:noFill/>
+        </p:spPr>
+        <p:txBody>
+          <a:bodyPr wrap="square">
+            <a:spAutoFit/>
+          </a:bodyPr>
+          <a:lstStyle/>
+          <a:p>
+            <a:pPr>
+              <a:spcAft>
+                <a:spcPts val="1200"/>
+              </a:spcAft>
+              <a:defRPr sz="2800" b="1">
+                <a:solidFill>
+                  <a:srgbClr val="17243A"/>
+                </a:solidFill>
+                <a:latin typeface="Aptos"/>
+              </a:defRPr>
+            </a:pPr>
+            <a:r>
+              <a:t>Recommendation: add data before changing weights</a:t>
+            </a:r>
+          </a:p>
+        </p:txBody>
+      </p:sp>
+      <p:sp>
+        <p:nvSpPr>
+          <p:cNvPr id="3" name="TextBox 2"/>
+          <p:cNvSpPr txBox="1"/>
+          <p:nvPr/>
+        </p:nvSpPr>
+        <p:spPr>
+          <a:xfrm>
+            <a:off x="457200" y="868680"/>
+            <a:ext cx="11247120" cy="502920"/>
+          </a:xfrm>
+          <a:prstGeom prst="rect">
+            <a:avLst/>
+          </a:prstGeom>
+          <a:noFill/>
+        </p:spPr>
+        <p:txBody>
+          <a:bodyPr wrap="square">
+            <a:spAutoFit/>
+          </a:bodyPr>
+          <a:lstStyle/>
+          <a:p>
+            <a:pPr>
+              <a:spcAft>
+                <a:spcPts val="1200"/>
+              </a:spcAft>
+              <a:defRPr sz="1500" b="0">
+                <a:solidFill>
+                  <a:srgbClr val="58677B"/>
+                </a:solidFill>
+                <a:latin typeface="Aptos"/>
+              </a:defRPr>
+            </a:pPr>
+            <a:r>
+              <a:t>Keep the first multi-dataset experiment interpretable by changing one factor at a time.</a:t>
+            </a:r>
+          </a:p>
+        </p:txBody>
+      </p:sp>
+      <p:sp>
+        <p:nvSpPr>
+          <p:cNvPr id="4" name="TextBox 3"/>
+          <p:cNvSpPr txBox="1"/>
+          <p:nvPr/>
+        </p:nvSpPr>
+        <p:spPr>
+          <a:xfrm>
+            <a:off x="457200" y="6473952"/>
+            <a:ext cx="10881360" cy="228600"/>
+          </a:xfrm>
+          <a:prstGeom prst="rect">
+            <a:avLst/>
+          </a:prstGeom>
+          <a:noFill/>
+        </p:spPr>
+        <p:txBody>
+          <a:bodyPr wrap="square">
+            <a:spAutoFit/>
+          </a:bodyPr>
+          <a:lstStyle/>
+          <a:p>
+            <a:pPr>
+              <a:spcAft>
+                <a:spcPts val="1200"/>
+              </a:spcAft>
+              <a:defRPr sz="900" b="0">
+                <a:solidFill>
+                  <a:srgbClr val="58677B"/>
+                </a:solidFill>
+                <a:latin typeface="Aptos"/>
+              </a:defRPr>
+            </a:pPr>
+            <a:r>
+              <a:t>Sources: full annotated intervention and loss-gradient audit; proposed experiment, not yet run</a:t>
+            </a:r>
+          </a:p>
+        </p:txBody>
+      </p:sp>
+      <p:sp>
+        <p:nvSpPr>
+          <p:cNvPr id="5" name="TextBox 4"/>
+          <p:cNvSpPr txBox="1"/>
+          <p:nvPr/>
+        </p:nvSpPr>
+        <p:spPr>
+          <a:xfrm>
+            <a:off x="11292840" y="6437376"/>
+            <a:ext cx="457200" cy="274320"/>
+          </a:xfrm>
+          <a:prstGeom prst="rect">
+            <a:avLst/>
+          </a:prstGeom>
+          <a:noFill/>
+        </p:spPr>
+        <p:txBody>
+          <a:bodyPr wrap="square">
+            <a:spAutoFit/>
+          </a:bodyPr>
+          <a:lstStyle/>
+          <a:p>
+            <a:pPr>
+              <a:spcAft>
+                <a:spcPts val="1200"/>
+              </a:spcAft>
+              <a:defRPr sz="1100" b="0">
+                <a:solidFill>
+                  <a:srgbClr val="58677B"/>
+                </a:solidFill>
+                <a:latin typeface="Aptos"/>
+              </a:defRPr>
+            </a:pPr>
+            <a:r>
+              <a:t>15</a:t>
+            </a:r>
+          </a:p>
+        </p:txBody>
+      </p:sp>
+      <p:graphicFrame>
+        <p:nvGraphicFramePr>
+          <p:cNvPr id="6" name="Table 5"/>
+          <p:cNvGraphicFramePr>
+            <a:graphicFrameLocks noGrp="1"/>
+          </p:cNvGraphicFramePr>
+          <p:nvPr/>
+        </p:nvGraphicFramePr>
+        <p:xfrm>
+          <a:off x="502920" y="1645920"/>
+          <a:ext cx="11155680" cy="2743200"/>
         </p:xfrm>
         <a:graphic>
           <a:graphicData uri="http://schemas.openxmlformats.org/drawingml/2006/table">
@@ -5886,7 +9573,7 @@
                 <a:gridCol w="5577840"/>
                 <a:gridCol w="5577840"/>
               </a:tblGrid>
-              <a:tr h="605790">
+              <a:tr h="548640">
                 <a:tc>
                   <a:txBody>
                     <a:bodyPr/>
@@ -5901,7 +9588,7 @@
                         </a:defRPr>
                       </a:pPr>
                       <a:r>
-                        <a:t>Supported by current experiments</a:t>
+                        <a:t>Evidence</a:t>
                       </a:r>
                     </a:p>
                   </a:txBody>
@@ -5925,7 +9612,7 @@
                         </a:defRPr>
                       </a:pPr>
                       <a:r>
-                        <a:t>Still unresolved</a:t>
+                        <a:t>Implication</a:t>
                       </a:r>
                     </a:p>
                   </a:txBody>
@@ -5936,22 +9623,22 @@
                   </a:tcPr>
                 </a:tc>
               </a:tr>
-              <a:tr h="605790">
-                <a:tc>
-                  <a:txBody>
-                    <a:bodyPr/>
-                    <a:lstStyle/>
-                    <a:p>
-                      <a:pPr>
-                        <a:defRPr sz="1600" b="0">
-                          <a:solidFill>
-                            <a:srgbClr val="17243A"/>
-                          </a:solidFill>
-                          <a:latin typeface="Aptos"/>
-                        </a:defRPr>
-                      </a:pPr>
-                      <a:r>
-                        <a:t>Refinement usually compensates for smaller projections.</a:t>
+              <a:tr h="548640">
+                <a:tc>
+                  <a:txBody>
+                    <a:bodyPr/>
+                    <a:lstStyle/>
+                    <a:p>
+                      <a:pPr>
+                        <a:defRPr sz="1600" b="0">
+                          <a:solidFill>
+                            <a:srgbClr val="17243A"/>
+                          </a:solidFill>
+                          <a:latin typeface="Aptos"/>
+                        </a:defRPr>
+                      </a:pPr>
+                      <a:r>
+                        <a:t>FreiHAND median extent / GT = 98.34%.</a:t>
                       </a:r>
                     </a:p>
                   </a:txBody>
@@ -5975,7 +9662,7 @@
                         </a:defRPr>
                       </a:pPr>
                       <a:r>
-                        <a:t>Whether official predictions are closer to ground truth.</a:t>
+                        <a:t>No strong systematic in-domain scale bias.</a:t>
                       </a:r>
                     </a:p>
                   </a:txBody>
@@ -5986,22 +9673,22 @@
                   </a:tcPr>
                 </a:tc>
               </a:tr>
-              <a:tr h="605790">
-                <a:tc>
-                  <a:txBody>
-                    <a:bodyPr/>
-                    <a:lstStyle/>
-                    <a:p>
-                      <a:pPr>
-                        <a:defRPr sz="1600" b="0">
-                          <a:solidFill>
-                            <a:srgbClr val="17243A"/>
-                          </a:solidFill>
-                          <a:latin typeface="Aptos"/>
-                        </a:defRPr>
-                      </a:pPr>
-                      <a:r>
-                        <a:t>Camera and global orientation affect the discrepancy.</a:t>
+              <a:tr h="548640">
+                <a:tc>
+                  <a:txBody>
+                    <a:bodyPr/>
+                    <a:lstStyle/>
+                    <a:p>
+                      <a:pPr>
+                        <a:defRPr sz="1600" b="0">
+                          <a:solidFill>
+                            <a:srgbClr val="17243A"/>
+                          </a:solidFill>
+                          <a:latin typeface="Aptos"/>
+                        </a:defRPr>
+                      </a:pPr>
+                      <a:r>
+                        <a:t>The larger size discrepancy appears on demo images.</a:t>
                       </a:r>
                     </a:p>
                   </a:txBody>
@@ -6025,7 +9712,7 @@
                         </a:defRPr>
                       </a:pPr>
                       <a:r>
-                        <a:t>Why training learned these camera/orientation predictions.</a:t>
+                        <a:t>Domain coverage is the stronger first hypothesis.</a:t>
                       </a:r>
                     </a:p>
                   </a:txBody>
@@ -6036,22 +9723,22 @@
                   </a:tcPr>
                 </a:tc>
               </a:tr>
-              <a:tr h="605790">
-                <a:tc>
-                  <a:txBody>
-                    <a:bodyPr/>
-                    <a:lstStyle/>
-                    <a:p>
-                      <a:pPr>
-                        <a:defRPr sz="1600" b="0">
-                          <a:solidFill>
-                            <a:srgbClr val="17243A"/>
-                          </a:solidFill>
-                          <a:latin typeface="Aptos"/>
-                        </a:defRPr>
-                      </a:pPr>
-                      <a:r>
-                        <a:t>Betas alone have a small median extent effect.</a:t>
+              <a:tr h="548640">
+                <a:tc>
+                  <a:txBody>
+                    <a:bodyPr/>
+                    <a:lstStyle/>
+                    <a:p>
+                      <a:pPr>
+                        <a:defRPr sz="1600" b="0">
+                          <a:solidFill>
+                            <a:srgbClr val="17243A"/>
+                          </a:solidFill>
+                          <a:latin typeface="Aptos"/>
+                        </a:defRPr>
+                      </a:pPr>
+                      <a:r>
+                        <a:t>All configured losses are active; betas contribute 6.64%.</a:t>
                       </a:r>
                     </a:p>
                   </a:txBody>
@@ -6075,13 +9762,63 @@
                         </a:defRPr>
                       </a:pPr>
                       <a:r>
-                        <a:t>Per-sample failures, false detections and domain shift.</a:t>
+                        <a:t>No failed or clearly absent loss requires an immediate weight fix.</a:t>
                       </a:r>
                     </a:p>
                   </a:txBody>
                   <a:tcPr marL="109728" marT="109728">
                     <a:solidFill>
                       <a:srgbClr val="FFFFFF"/>
+                    </a:solidFill>
+                  </a:tcPr>
+                </a:tc>
+              </a:tr>
+              <a:tr h="548640">
+                <a:tc>
+                  <a:txBody>
+                    <a:bodyPr/>
+                    <a:lstStyle/>
+                    <a:p>
+                      <a:pPr>
+                        <a:defRPr sz="1600" b="0">
+                          <a:solidFill>
+                            <a:srgbClr val="17243A"/>
+                          </a:solidFill>
+                          <a:latin typeface="Aptos"/>
+                        </a:defRPr>
+                      </a:pPr>
+                      <a:r>
+                        <a:t>Official WiLoR used broader training data.</a:t>
+                      </a:r>
+                    </a:p>
+                  </a:txBody>
+                  <a:tcPr marL="109728" marT="109728">
+                    <a:solidFill>
+                      <a:srgbClr val="E8EEF4"/>
+                    </a:solidFill>
+                  </a:tcPr>
+                </a:tc>
+                <a:tc>
+                  <a:txBody>
+                    <a:bodyPr/>
+                    <a:lstStyle/>
+                    <a:p>
+                      <a:pPr>
+                        <a:defRPr sz="1600" b="0">
+                          <a:solidFill>
+                            <a:srgbClr val="17243A"/>
+                          </a:solidFill>
+                          <a:latin typeface="Aptos"/>
+                        </a:defRPr>
+                      </a:pPr>
+                      <a:r>
+                        <a:t>Add WHIM alongside FreiHAND before tuning the objective.</a:t>
+                      </a:r>
+                    </a:p>
+                  </a:txBody>
+                  <a:tcPr marL="109728" marT="109728">
+                    <a:solidFill>
+                      <a:srgbClr val="E8EEF4"/>
                     </a:solidFill>
                   </a:tcPr>
                 </a:tc>
@@ -6098,8 +9835,8 @@
         </p:nvSpPr>
         <p:spPr>
           <a:xfrm>
-            <a:off x="594360" y="4389120"/>
-            <a:ext cx="10972800" cy="1554480"/>
+            <a:off x="594360" y="4526280"/>
+            <a:ext cx="10972800" cy="1417320"/>
           </a:xfrm>
           <a:prstGeom prst="rect">
             <a:avLst/>
@@ -6116,7 +9853,7 @@
               <a:spcAft>
                 <a:spcPts val="1200"/>
               </a:spcAft>
-              <a:defRPr sz="2000" b="0">
+              <a:defRPr sz="1800" b="0">
                 <a:solidFill>
                   <a:srgbClr val="007F86"/>
                 </a:solidFill>
@@ -6124,7 +9861,7 @@
               </a:defRPr>
             </a:pPr>
             <a:r>
-              <a:t>Next: audit crop-to-image projection, left-hand mirroring and renderer conventions.</a:t>
+              <a:t>Protocol: same ViTPose initialization, architecture, optimizer and current loss weights; change only the data mixture.</a:t>
             </a:r>
           </a:p>
           <a:p>
@@ -6132,7 +9869,7 @@
               <a:spcAft>
                 <a:spcPts val="1200"/>
               </a:spcAft>
-              <a:defRPr sz="2000" b="0">
+              <a:defRPr sz="1800" b="0">
                 <a:solidFill>
                   <a:srgbClr val="007F86"/>
                 </a:solidFill>
@@ -6140,7 +9877,7 @@
               </a:defRPr>
             </a:pPr>
             <a:r>
-              <a:t>Then repeat targeted tests on annotated FreiHAND samples and inspect effective losses/gradients.</a:t>
+              <a:t>Start with a 1,000-step FreiHAND + WHIM smoke run, verify sampling and validation, then scale up only if metrics and fixed-demo outputs improve.</a:t>
             </a:r>
           </a:p>
           <a:p>
@@ -6148,7 +9885,7 @@
               <a:spcAft>
                 <a:spcPts val="1200"/>
               </a:spcAft>
-              <a:defRPr sz="2000" b="0">
+              <a:defRPr sz="1800" b="0">
                 <a:solidFill>
                   <a:srgbClr val="007F86"/>
                 </a:solidFill>
@@ -6156,7 +9893,536 @@
               </a:defRPr>
             </a:pPr>
             <a:r>
-              <a:t>Choose a short repair run only after these checks; no loss-weight fix is yet established.</a:t>
+              <a:t>Judge MPJPE, PA-MPJPE, PVE and reprojection together—not projected extent alone.</a:t>
+            </a:r>
+          </a:p>
+        </p:txBody>
+      </p:sp>
+    </p:spTree>
+  </p:cSld>
+  <p:clrMapOvr>
+    <a:masterClrMapping/>
+  </p:clrMapOvr>
+</p:sld>
+</file>
+
+<file path=ppt/slides/slide16.xml><?xml version="1.0" encoding="utf-8"?>
+<p:sld xmlns:a="http://schemas.openxmlformats.org/drawingml/2006/main" xmlns:p="http://schemas.openxmlformats.org/presentationml/2006/main" xmlns:r="http://schemas.openxmlformats.org/officeDocument/2006/relationships">
+  <p:cSld>
+    <p:bg>
+      <p:bgPr>
+        <a:solidFill>
+          <a:srgbClr val="F4F6FA"/>
+        </a:solidFill>
+        <a:effectLst/>
+      </p:bgPr>
+    </p:bg>
+    <p:spTree>
+      <p:nvGrpSpPr>
+        <p:cNvPr id="1" name=""/>
+        <p:cNvGrpSpPr/>
+        <p:nvPr/>
+      </p:nvGrpSpPr>
+      <p:grpSpPr/>
+      <p:sp>
+        <p:nvSpPr>
+          <p:cNvPr id="2" name="TextBox 1"/>
+          <p:cNvSpPr txBox="1"/>
+          <p:nvPr/>
+        </p:nvSpPr>
+        <p:spPr>
+          <a:xfrm>
+            <a:off x="457200" y="201168"/>
+            <a:ext cx="11247120" cy="548640"/>
+          </a:xfrm>
+          <a:prstGeom prst="rect">
+            <a:avLst/>
+          </a:prstGeom>
+          <a:noFill/>
+        </p:spPr>
+        <p:txBody>
+          <a:bodyPr wrap="square">
+            <a:spAutoFit/>
+          </a:bodyPr>
+          <a:lstStyle/>
+          <a:p>
+            <a:pPr>
+              <a:spcAft>
+                <a:spcPts val="1200"/>
+              </a:spcAft>
+              <a:defRPr sz="2800" b="1">
+                <a:solidFill>
+                  <a:srgbClr val="17243A"/>
+                </a:solidFill>
+                <a:latin typeface="Aptos"/>
+              </a:defRPr>
+            </a:pPr>
+            <a:r>
+              <a:t>Conclusions and the next decision</a:t>
+            </a:r>
+          </a:p>
+        </p:txBody>
+      </p:sp>
+      <p:sp>
+        <p:nvSpPr>
+          <p:cNvPr id="3" name="TextBox 2"/>
+          <p:cNvSpPr txBox="1"/>
+          <p:nvPr/>
+        </p:nvSpPr>
+        <p:spPr>
+          <a:xfrm>
+            <a:off x="457200" y="868680"/>
+            <a:ext cx="11247120" cy="502920"/>
+          </a:xfrm>
+          <a:prstGeom prst="rect">
+            <a:avLst/>
+          </a:prstGeom>
+          <a:noFill/>
+        </p:spPr>
+        <p:txBody>
+          <a:bodyPr wrap="square">
+            <a:spAutoFit/>
+          </a:bodyPr>
+          <a:lstStyle/>
+          <a:p>
+            <a:pPr>
+              <a:spcAft>
+                <a:spcPts val="1200"/>
+              </a:spcAft>
+              <a:defRPr sz="1500" b="0">
+                <a:solidFill>
+                  <a:srgbClr val="58677B"/>
+                </a:solidFill>
+                <a:latin typeface="Aptos"/>
+              </a:defRPr>
+            </a:pPr>
+            <a:r>
+              <a:t>Current evidence supports a controlled multi-dataset experiment before loss tuning.</a:t>
+            </a:r>
+          </a:p>
+        </p:txBody>
+      </p:sp>
+      <p:sp>
+        <p:nvSpPr>
+          <p:cNvPr id="4" name="TextBox 3"/>
+          <p:cNvSpPr txBox="1"/>
+          <p:nvPr/>
+        </p:nvSpPr>
+        <p:spPr>
+          <a:xfrm>
+            <a:off x="457200" y="6473952"/>
+            <a:ext cx="10881360" cy="228600"/>
+          </a:xfrm>
+          <a:prstGeom prst="rect">
+            <a:avLst/>
+          </a:prstGeom>
+          <a:noFill/>
+        </p:spPr>
+        <p:txBody>
+          <a:bodyPr wrap="square">
+            <a:spAutoFit/>
+          </a:bodyPr>
+          <a:lstStyle/>
+          <a:p>
+            <a:pPr>
+              <a:spcAft>
+                <a:spcPts val="1200"/>
+              </a:spcAft>
+              <a:defRPr sz="900" b="0">
+                <a:solidFill>
+                  <a:srgbClr val="58677B"/>
+                </a:solidFill>
+                <a:latin typeface="Aptos"/>
+              </a:defRPr>
+            </a:pPr>
+            <a:r>
+              <a:t>Sources: full annotated intervention, loss-gradient audit and all local scale_diagnostic reports</a:t>
+            </a:r>
+          </a:p>
+        </p:txBody>
+      </p:sp>
+      <p:sp>
+        <p:nvSpPr>
+          <p:cNvPr id="5" name="TextBox 4"/>
+          <p:cNvSpPr txBox="1"/>
+          <p:nvPr/>
+        </p:nvSpPr>
+        <p:spPr>
+          <a:xfrm>
+            <a:off x="11292840" y="6437376"/>
+            <a:ext cx="457200" cy="274320"/>
+          </a:xfrm>
+          <a:prstGeom prst="rect">
+            <a:avLst/>
+          </a:prstGeom>
+          <a:noFill/>
+        </p:spPr>
+        <p:txBody>
+          <a:bodyPr wrap="square">
+            <a:spAutoFit/>
+          </a:bodyPr>
+          <a:lstStyle/>
+          <a:p>
+            <a:pPr>
+              <a:spcAft>
+                <a:spcPts val="1200"/>
+              </a:spcAft>
+              <a:defRPr sz="1100" b="0">
+                <a:solidFill>
+                  <a:srgbClr val="58677B"/>
+                </a:solidFill>
+                <a:latin typeface="Aptos"/>
+              </a:defRPr>
+            </a:pPr>
+            <a:r>
+              <a:t>16</a:t>
+            </a:r>
+          </a:p>
+        </p:txBody>
+      </p:sp>
+      <p:graphicFrame>
+        <p:nvGraphicFramePr>
+          <p:cNvPr id="6" name="Table 5"/>
+          <p:cNvGraphicFramePr>
+            <a:graphicFrameLocks noGrp="1"/>
+          </p:cNvGraphicFramePr>
+          <p:nvPr/>
+        </p:nvGraphicFramePr>
+        <p:xfrm>
+          <a:off x="502920" y="1645920"/>
+          <a:ext cx="11155680" cy="2880360"/>
+        </p:xfrm>
+        <a:graphic>
+          <a:graphicData uri="http://schemas.openxmlformats.org/drawingml/2006/table">
+            <a:tbl>
+              <a:tblPr firstRow="1" bandRow="1">
+                <a:tableStyleId>{5C22544A-7EE6-4342-B048-85BDC9FD1C3A}</a:tableStyleId>
+              </a:tblPr>
+              <a:tblGrid>
+                <a:gridCol w="5577840"/>
+                <a:gridCol w="5577840"/>
+              </a:tblGrid>
+              <a:tr h="576072">
+                <a:tc>
+                  <a:txBody>
+                    <a:bodyPr/>
+                    <a:lstStyle/>
+                    <a:p>
+                      <a:pPr>
+                        <a:defRPr sz="1600" b="1">
+                          <a:solidFill>
+                            <a:srgbClr val="FFFFFF"/>
+                          </a:solidFill>
+                          <a:latin typeface="Aptos"/>
+                        </a:defRPr>
+                      </a:pPr>
+                      <a:r>
+                        <a:t>Supported by current experiments</a:t>
+                      </a:r>
+                    </a:p>
+                  </a:txBody>
+                  <a:tcPr marL="109728" marT="109728">
+                    <a:solidFill>
+                      <a:srgbClr val="17243A"/>
+                    </a:solidFill>
+                  </a:tcPr>
+                </a:tc>
+                <a:tc>
+                  <a:txBody>
+                    <a:bodyPr/>
+                    <a:lstStyle/>
+                    <a:p>
+                      <a:pPr>
+                        <a:defRPr sz="1600" b="1">
+                          <a:solidFill>
+                            <a:srgbClr val="FFFFFF"/>
+                          </a:solidFill>
+                          <a:latin typeface="Aptos"/>
+                        </a:defRPr>
+                      </a:pPr>
+                      <a:r>
+                        <a:t>Still unresolved</a:t>
+                      </a:r>
+                    </a:p>
+                  </a:txBody>
+                  <a:tcPr marL="109728" marT="109728">
+                    <a:solidFill>
+                      <a:srgbClr val="17243A"/>
+                    </a:solidFill>
+                  </a:tcPr>
+                </a:tc>
+              </a:tr>
+              <a:tr h="576072">
+                <a:tc>
+                  <a:txBody>
+                    <a:bodyPr/>
+                    <a:lstStyle/>
+                    <a:p>
+                      <a:pPr>
+                        <a:defRPr sz="1600" b="0">
+                          <a:solidFill>
+                            <a:srgbClr val="17243A"/>
+                          </a:solidFill>
+                          <a:latin typeface="Aptos"/>
+                        </a:defRPr>
+                      </a:pPr>
+                      <a:r>
+                        <a:t>Refinement usually compensates for smaller demo projections.</a:t>
+                      </a:r>
+                    </a:p>
+                  </a:txBody>
+                  <a:tcPr marL="109728" marT="109728">
+                    <a:solidFill>
+                      <a:srgbClr val="FFFFFF"/>
+                    </a:solidFill>
+                  </a:tcPr>
+                </a:tc>
+                <a:tc>
+                  <a:txBody>
+                    <a:bodyPr/>
+                    <a:lstStyle/>
+                    <a:p>
+                      <a:pPr>
+                        <a:defRPr sz="1600" b="0">
+                          <a:solidFill>
+                            <a:srgbClr val="17243A"/>
+                          </a:solidFill>
+                          <a:latin typeface="Aptos"/>
+                        </a:defRPr>
+                      </a:pPr>
+                      <a:r>
+                        <a:t>Why the demo domain shows a larger size discrepancy.</a:t>
+                      </a:r>
+                    </a:p>
+                  </a:txBody>
+                  <a:tcPr marL="109728" marT="109728">
+                    <a:solidFill>
+                      <a:srgbClr val="FFFFFF"/>
+                    </a:solidFill>
+                  </a:tcPr>
+                </a:tc>
+              </a:tr>
+              <a:tr h="576072">
+                <a:tc>
+                  <a:txBody>
+                    <a:bodyPr/>
+                    <a:lstStyle/>
+                    <a:p>
+                      <a:pPr>
+                        <a:defRPr sz="1600" b="0">
+                          <a:solidFill>
+                            <a:srgbClr val="17243A"/>
+                          </a:solidFill>
+                          <a:latin typeface="Aptos"/>
+                        </a:defRPr>
+                      </a:pPr>
+                      <a:r>
+                        <a:t>No strong systematic FreiHAND scale shrinkage (98.34% median extent / GT).</a:t>
+                      </a:r>
+                    </a:p>
+                  </a:txBody>
+                  <a:tcPr marL="109728" marT="109728">
+                    <a:solidFill>
+                      <a:srgbClr val="E8EEF4"/>
+                    </a:solidFill>
+                  </a:tcPr>
+                </a:tc>
+                <a:tc>
+                  <a:txBody>
+                    <a:bodyPr/>
+                    <a:lstStyle/>
+                    <a:p>
+                      <a:pPr>
+                        <a:defRPr sz="1600" b="0">
+                          <a:solidFill>
+                            <a:srgbClr val="17243A"/>
+                          </a:solidFill>
+                          <a:latin typeface="Aptos"/>
+                        </a:defRPr>
+                      </a:pPr>
+                      <a:r>
+                        <a:t>Whether more varied training data fixes out-of-domain scale behavior.</a:t>
+                      </a:r>
+                    </a:p>
+                  </a:txBody>
+                  <a:tcPr marL="109728" marT="109728">
+                    <a:solidFill>
+                      <a:srgbClr val="E8EEF4"/>
+                    </a:solidFill>
+                  </a:tcPr>
+                </a:tc>
+              </a:tr>
+              <a:tr h="576072">
+                <a:tc>
+                  <a:txBody>
+                    <a:bodyPr/>
+                    <a:lstStyle/>
+                    <a:p>
+                      <a:pPr>
+                        <a:defRPr sz="1600" b="0">
+                          <a:solidFill>
+                            <a:srgbClr val="17243A"/>
+                          </a:solidFill>
+                          <a:latin typeface="Aptos"/>
+                        </a:defRPr>
+                      </a:pPr>
+                      <a:r>
+                        <a:t>Pose—especially fingers—is the main annotated accuracy gap.</a:t>
+                      </a:r>
+                    </a:p>
+                  </a:txBody>
+                  <a:tcPr marL="109728" marT="109728">
+                    <a:solidFill>
+                      <a:srgbClr val="FFFFFF"/>
+                    </a:solidFill>
+                  </a:tcPr>
+                </a:tc>
+                <a:tc>
+                  <a:txBody>
+                    <a:bodyPr/>
+                    <a:lstStyle/>
+                    <a:p>
+                      <a:pPr>
+                        <a:defRPr sz="1600" b="0">
+                          <a:solidFill>
+                            <a:srgbClr val="17243A"/>
+                          </a:solidFill>
+                          <a:latin typeface="Aptos"/>
+                        </a:defRPr>
+                      </a:pPr>
+                      <a:r>
+                        <a:t>The best FreiHAND/WHIM sampling ratio and coverage.</a:t>
+                      </a:r>
+                    </a:p>
+                  </a:txBody>
+                  <a:tcPr marL="109728" marT="109728">
+                    <a:solidFill>
+                      <a:srgbClr val="FFFFFF"/>
+                    </a:solidFill>
+                  </a:tcPr>
+                </a:tc>
+              </a:tr>
+              <a:tr h="576072">
+                <a:tc>
+                  <a:txBody>
+                    <a:bodyPr/>
+                    <a:lstStyle/>
+                    <a:p>
+                      <a:pPr>
+                        <a:defRPr sz="1600" b="0">
+                          <a:solidFill>
+                            <a:srgbClr val="17243A"/>
+                          </a:solidFill>
+                          <a:latin typeface="Aptos"/>
+                        </a:defRPr>
+                      </a:pPr>
+                      <a:r>
+                        <a:t>Camera and geometry are co-adapted; isolated swapping is misleading.</a:t>
+                      </a:r>
+                    </a:p>
+                  </a:txBody>
+                  <a:tcPr marL="109728" marT="109728">
+                    <a:solidFill>
+                      <a:srgbClr val="E8EEF4"/>
+                    </a:solidFill>
+                  </a:tcPr>
+                </a:tc>
+                <a:tc>
+                  <a:txBody>
+                    <a:bodyPr/>
+                    <a:lstStyle/>
+                    <a:p>
+                      <a:pPr>
+                        <a:defRPr sz="1600" b="0">
+                          <a:solidFill>
+                            <a:srgbClr val="17243A"/>
+                          </a:solidFill>
+                          <a:latin typeface="Aptos"/>
+                        </a:defRPr>
+                      </a:pPr>
+                      <a:r>
+                        <a:t>Per-sample failures, false detections and domain shift.</a:t>
+                      </a:r>
+                    </a:p>
+                  </a:txBody>
+                  <a:tcPr marL="109728" marT="109728">
+                    <a:solidFill>
+                      <a:srgbClr val="E8EEF4"/>
+                    </a:solidFill>
+                  </a:tcPr>
+                </a:tc>
+              </a:tr>
+            </a:tbl>
+          </a:graphicData>
+        </a:graphic>
+      </p:graphicFrame>
+      <p:sp>
+        <p:nvSpPr>
+          <p:cNvPr id="7" name="TextBox 6"/>
+          <p:cNvSpPr txBox="1"/>
+          <p:nvPr/>
+        </p:nvSpPr>
+        <p:spPr>
+          <a:xfrm>
+            <a:off x="594360" y="4800600"/>
+            <a:ext cx="10972800" cy="1234440"/>
+          </a:xfrm>
+          <a:prstGeom prst="rect">
+            <a:avLst/>
+          </a:prstGeom>
+          <a:noFill/>
+        </p:spPr>
+        <p:txBody>
+          <a:bodyPr wrap="square">
+            <a:spAutoFit/>
+          </a:bodyPr>
+          <a:lstStyle/>
+          <a:p>
+            <a:pPr>
+              <a:spcAft>
+                <a:spcPts val="1200"/>
+              </a:spcAft>
+              <a:defRPr sz="1900" b="0">
+                <a:solidFill>
+                  <a:srgbClr val="007F86"/>
+                </a:solidFill>
+                <a:latin typeface="Aptos"/>
+              </a:defRPr>
+            </a:pPr>
+            <a:r>
+              <a:t>Next: add WHIM and run a 1,000-step FreiHAND + WHIM smoke test with the current loss weights unchanged.</a:t>
+            </a:r>
+          </a:p>
+          <a:p>
+            <a:pPr>
+              <a:spcAft>
+                <a:spcPts val="1200"/>
+              </a:spcAft>
+              <a:defRPr sz="1900" b="0">
+                <a:solidFill>
+                  <a:srgbClr val="007F86"/>
+                </a:solidFill>
+                <a:latin typeface="Aptos"/>
+              </a:defRPr>
+            </a:pPr>
+            <a:r>
+              <a:t>Use the same ViTPose initialization, architecture and optimizer so the data effect remains identifiable.</a:t>
+            </a:r>
+          </a:p>
+          <a:p>
+            <a:pPr>
+              <a:spcAft>
+                <a:spcPts val="1200"/>
+              </a:spcAft>
+              <a:defRPr sz="1900" b="0">
+                <a:solidFill>
+                  <a:srgbClr val="007F86"/>
+                </a:solidFill>
+                <a:latin typeface="Aptos"/>
+              </a:defRPr>
+            </a:pPr>
+            <a:r>
+              <a:t>Select by full validation MPJPE, PA-MPJPE, PVE and reprojection—not projected extent alone.</a:t>
             </a:r>
           </a:p>
         </p:txBody>
@@ -7596,7 +11862,7 @@
               </a:defRPr>
             </a:pPr>
             <a:r>
-              <a:t>All rows use 10,240 samples. Lower is better. HaMeR has not been evaluated in this table.</a:t>
+              <a:t>10,240 historical samples. Reprojection corrected arithmetically; no new evaluation.</a:t>
             </a:r>
           </a:p>
         </p:txBody>
@@ -7635,7 +11901,7 @@
               </a:defRPr>
             </a:pPr>
             <a:r>
-              <a:t>Source: evaluation/freihand_full_comparison/metrics.csv; scripts/evaluate_freihand.py</a:t>
+              <a:t>Source: evaluation/freihand_full_comparison_corrected/metrics.csv; projection_audit/report.md</a:t>
             </a:r>
           </a:p>
         </p:txBody>
@@ -7937,7 +12203,7 @@
                         </a:defRPr>
                       </a:pPr>
                       <a:r>
-                        <a:t>86.117</a:t>
+                        <a:t>172.234</a:t>
                       </a:r>
                     </a:p>
                   </a:txBody>
@@ -8059,7 +12325,7 @@
                         </a:defRPr>
                       </a:pPr>
                       <a:r>
-                        <a:t>3.372</a:t>
+                        <a:t>6.743</a:t>
                       </a:r>
                     </a:p>
                   </a:txBody>
@@ -8181,7 +12447,7 @@
                         </a:defRPr>
                       </a:pPr>
                       <a:r>
-                        <a:t>1.596</a:t>
+                        <a:t>3.192</a:t>
                       </a:r>
                     </a:p>
                   </a:txBody>
@@ -8269,7 +12535,7 @@
               </a:defRPr>
             </a:pPr>
             <a:r>
-              <a:t>Internal shard split, not the official FreiHAND benchmark. Independence of source captures/background variants and official training overlap have not been audited.</a:t>
+              <a:t>Internal shard split, not the official benchmark. Capture independence and official training overlap remain unaudited; no HaMeR evaluation in this table.</a:t>
             </a:r>
           </a:p>
           <a:p>
@@ -8285,7 +12551,7 @@
               </a:defRPr>
             </a:pPr>
             <a:r>
-              <a:t>¹ Stored crop-space reprojection metric; pixel normalization remains to be audited.</a:t>
+              <a:t>¹ Corrected crop-pixel error: old values ×2. Training loss and 3D metrics are unchanged.</a:t>
             </a:r>
           </a:p>
         </p:txBody>
@@ -9656,7 +13922,7 @@
               </a:defRPr>
             </a:pPr>
             <a:r>
-              <a:t>Camera swap: camera prediction contributes</a:t>
+              <a:t>Demo camera swap raised a hypothesis</a:t>
             </a:r>
           </a:p>
         </p:txBody>
@@ -10209,7 +14475,7 @@
               </a:defRPr>
             </a:pPr>
             <a:r>
-              <a:t>The trained geometry reaches 98.83% with the official camera, versus 93.61% with its own.</a:t>
+              <a:t>The trained geometry reaches 98.83% of the official extent with the official camera, versus 93.61% with its own.</a:t>
             </a:r>
           </a:p>
           <a:p>
@@ -10225,7 +14491,7 @@
               </a:defRPr>
             </a:pPr>
             <a:r>
-              <a:t>Camera matters, but this is not a causal percentage allocation or a ground-truth accuracy test.</a:t>
+              <a:t>This visual-reference result is not a ground-truth accuracy test; the full annotated intervention later shows that the swap worsens reprojection.</a:t>
             </a:r>
           </a:p>
         </p:txBody>

</xml_diff>